<commit_message>
adding thing in ppt
</commit_message>
<xml_diff>
--- a/presentation/Bank_Management_System_Presentation.pptx
+++ b/presentation/Bank_Management_System_Presentation.pptx
@@ -4,6 +4,9 @@
   <p:sldMasterIdLst>
     <p:sldMasterId id="2147483648" r:id="rId1"/>
   </p:sldMasterIdLst>
+  <p:notesMasterIdLst>
+    <p:notesMasterId r:id="rId14"/>
+  </p:notesMasterIdLst>
   <p:sldIdLst>
     <p:sldId id="256" r:id="rId2"/>
     <p:sldId id="257" r:id="rId3"/>
@@ -18,9 +21,6 @@
     <p:sldId id="266" r:id="rId12"/>
     <p:sldId id="267" r:id="rId13"/>
   </p:sldIdLst>
-  <p:notesMasterIdLst>
-    <p:notesMasterId r:id="rId14"/>
-  </p:notesMasterIdLst>
   <p:sldSz cx="12192000" cy="6858000"/>
   <p:notesSz cx="6858000" cy="12192000"/>
   <p:defaultTextStyle>
@@ -115,7 +115,49 @@
       </a:defRPr>
     </a:lvl9pPr>
   </p:defaultTextStyle>
+  <p:extLst>
+    <p:ext uri="{EFAFB233-063F-42B5-8137-9DF3F51BA10A}">
+      <p15:sldGuideLst xmlns:p15="http://schemas.microsoft.com/office/powerpoint/2012/main"/>
+    </p:ext>
+  </p:extLst>
 </p:presentation>
+</file>
+
+<file path=ppt/changesInfos/changesInfo1.xml><?xml version="1.0" encoding="utf-8"?>
+<pc:chgInfo xmlns:a="http://schemas.openxmlformats.org/drawingml/2006/main" xmlns:r="http://schemas.openxmlformats.org/officeDocument/2006/relationships" xmlns:ac="http://schemas.microsoft.com/office/drawing/2013/main/command" xmlns:pc="http://schemas.microsoft.com/office/powerpoint/2013/main/command">
+  <pc:docChgLst>
+    <pc:chgData name="harsh kumar" userId="e15134cc0c945bdb" providerId="LiveId" clId="{2ABE0526-E7C4-41E7-AD86-D4294807605F}"/>
+    <pc:docChg chg="modSld">
+      <pc:chgData name="harsh kumar" userId="e15134cc0c945bdb" providerId="LiveId" clId="{2ABE0526-E7C4-41E7-AD86-D4294807605F}" dt="2026-07-26T20:31:18.718" v="104" actId="20577"/>
+      <pc:docMkLst>
+        <pc:docMk/>
+      </pc:docMkLst>
+      <pc:sldChg chg="modSp mod">
+        <pc:chgData name="harsh kumar" userId="e15134cc0c945bdb" providerId="LiveId" clId="{2ABE0526-E7C4-41E7-AD86-D4294807605F}" dt="2026-07-26T20:31:18.718" v="104" actId="20577"/>
+        <pc:sldMkLst>
+          <pc:docMk/>
+          <pc:sldMk cId="0" sldId="256"/>
+        </pc:sldMkLst>
+        <pc:spChg chg="mod">
+          <ac:chgData name="harsh kumar" userId="e15134cc0c945bdb" providerId="LiveId" clId="{2ABE0526-E7C4-41E7-AD86-D4294807605F}" dt="2026-07-26T20:31:18.718" v="104" actId="20577"/>
+          <ac:spMkLst>
+            <pc:docMk/>
+            <pc:sldMk cId="0" sldId="256"/>
+            <ac:spMk id="10" creationId="{00000000-0000-0000-0000-000000000000}"/>
+          </ac:spMkLst>
+        </pc:spChg>
+        <pc:spChg chg="mod">
+          <ac:chgData name="harsh kumar" userId="e15134cc0c945bdb" providerId="LiveId" clId="{2ABE0526-E7C4-41E7-AD86-D4294807605F}" dt="2026-07-26T20:30:51.371" v="84" actId="20577"/>
+          <ac:spMkLst>
+            <pc:docMk/>
+            <pc:sldMk cId="0" sldId="256"/>
+            <ac:spMk id="11" creationId="{00000000-0000-0000-0000-000000000000}"/>
+          </ac:spMkLst>
+        </pc:spChg>
+      </pc:sldChg>
+    </pc:docChg>
+  </pc:docChgLst>
+</pc:chgInfo>
 </file>
 
 <file path=ppt/notesMasters/notesMaster1.xml><?xml version="1.0" encoding="utf-8"?>
@@ -140,234 +182,10 @@
           <a:chExt cx="0" cy="0"/>
         </a:xfrm>
       </p:grpSpPr>
-      <p:sp>
-        <p:nvSpPr>
-          <p:cNvPr id="2" name="Header Placeholder 1"/>
-          <p:cNvSpPr>
-            <a:spLocks noGrp="1"/>
-          </p:cNvSpPr>
-          <p:nvPr>
-            <p:ph type="hdr" sz="quarter"/>
-          </p:nvPr>
-        </p:nvSpPr>
-        <p:spPr>
-          <a:xfrm>
-            <a:off x="0" y="0"/>
-            <a:ext cx="2971800" cy="458788"/>
-          </a:xfrm>
-          <a:prstGeom prst="rect">
-            <a:avLst/>
-          </a:prstGeom>
-        </p:spPr>
-        <p:txBody>
-          <a:bodyPr vert="horz" lIns="91440" tIns="45720" rIns="91440" bIns="45720" rtlCol="0"/>
-          <a:lstStyle>
-            <a:lvl1pPr algn="l">
-              <a:defRPr sz="1200"/>
-            </a:lvl1pPr>
-          </a:lstStyle>
-          <a:p>
-            <a:endParaRPr lang="en-US"/>
-          </a:p>
-        </p:txBody>
-      </p:sp>
-      <p:sp>
-        <p:nvSpPr>
-          <p:cNvPr id="3" name="Date Placeholder 2"/>
-          <p:cNvSpPr>
-            <a:spLocks noGrp="1"/>
-          </p:cNvSpPr>
-          <p:nvPr>
-            <p:ph type="dt" idx="1"/>
-          </p:nvPr>
-        </p:nvSpPr>
-        <p:spPr>
-          <a:xfrm>
-            <a:off x="3884613" y="0"/>
-            <a:ext cx="2971800" cy="458788"/>
-          </a:xfrm>
-          <a:prstGeom prst="rect">
-            <a:avLst/>
-          </a:prstGeom>
-        </p:spPr>
-        <p:txBody>
-          <a:bodyPr vert="horz" lIns="91440" tIns="45720" rIns="91440" bIns="45720" rtlCol="0"/>
-          <a:lstStyle>
-            <a:lvl1pPr algn="r">
-              <a:defRPr sz="1200"/>
-            </a:lvl1pPr>
-          </a:lstStyle>
-          <a:p>
-            <a:fld id="{5282F153-3F37-0F45-9E97-73ACFA13230C}" type="datetimeFigureOut">
-              <a:rPr lang="en-US"/>
-              <a:t>7/23/19</a:t>
-            </a:fld>
-            <a:endParaRPr lang="en-US"/>
-          </a:p>
-        </p:txBody>
-      </p:sp>
-      <p:sp>
-        <p:nvSpPr>
-          <p:cNvPr id="4" name="Slide Image Placeholder 3"/>
-          <p:cNvSpPr>
-            <a:spLocks noGrp="1" noRot="1" noChangeAspect="1"/>
-          </p:cNvSpPr>
-          <p:nvPr>
-            <p:ph type="sldImg" idx="2"/>
-          </p:nvPr>
-        </p:nvSpPr>
-        <p:spPr>
-          <a:xfrm>
-            <a:off x="685800" y="1143000"/>
-            <a:ext cx="5486400" cy="3086100"/>
-          </a:xfrm>
-          <a:prstGeom prst="rect">
-            <a:avLst/>
-          </a:prstGeom>
-          <a:noFill/>
-          <a:ln w="12700">
-            <a:solidFill>
-              <a:prstClr val="black"/>
-            </a:solidFill>
-          </a:ln>
-        </p:spPr>
-        <p:txBody>
-          <a:bodyPr vert="horz" lIns="91440" tIns="45720" rIns="91440" bIns="45720" rtlCol="0" anchor="ctr"/>
-          <a:lstStyle/>
-          <a:p>
-            <a:endParaRPr lang="en-US"/>
-          </a:p>
-        </p:txBody>
-      </p:sp>
-      <p:sp>
-        <p:nvSpPr>
-          <p:cNvPr id="5" name="Notes Placeholder 4"/>
-          <p:cNvSpPr>
-            <a:spLocks noGrp="1"/>
-          </p:cNvSpPr>
-          <p:nvPr>
-            <p:ph type="body" sz="quarter" idx="3"/>
-          </p:nvPr>
-        </p:nvSpPr>
-        <p:spPr>
-          <a:xfrm>
-            <a:off x="685800" y="4400550"/>
-            <a:ext cx="5486400" cy="3600450"/>
-          </a:xfrm>
-          <a:prstGeom prst="rect">
-            <a:avLst/>
-          </a:prstGeom>
-        </p:spPr>
-        <p:txBody>
-          <a:bodyPr vert="horz" lIns="91440" tIns="45720" rIns="91440" bIns="45720" rtlCol="0"/>
-          <a:lstStyle/>
-          <a:p>
-            <a:pPr lvl="0"/>
-            <a:r>
-              <a:rPr lang="en-US"/>
-              <a:t>Click to edit Master text styles</a:t>
-            </a:r>
-          </a:p>
-          <a:p>
-            <a:pPr lvl="1"/>
-            <a:r>
-              <a:rPr lang="en-US"/>
-              <a:t>Second level</a:t>
-            </a:r>
-          </a:p>
-          <a:p>
-            <a:pPr lvl="2"/>
-            <a:r>
-              <a:rPr lang="en-US"/>
-              <a:t>Third level</a:t>
-            </a:r>
-          </a:p>
-          <a:p>
-            <a:pPr lvl="3"/>
-            <a:r>
-              <a:rPr lang="en-US"/>
-              <a:t>Fourth level</a:t>
-            </a:r>
-          </a:p>
-          <a:p>
-            <a:pPr lvl="4"/>
-            <a:r>
-              <a:rPr lang="en-US"/>
-              <a:t>Fifth level</a:t>
-            </a:r>
-          </a:p>
-        </p:txBody>
-      </p:sp>
-      <p:sp>
-        <p:nvSpPr>
-          <p:cNvPr id="6" name="Footer Placeholder 5"/>
-          <p:cNvSpPr>
-            <a:spLocks noGrp="1"/>
-          </p:cNvSpPr>
-          <p:nvPr>
-            <p:ph type="ftr" sz="quarter" idx="4"/>
-          </p:nvPr>
-        </p:nvSpPr>
-        <p:spPr>
-          <a:xfrm>
-            <a:off x="0" y="8685213"/>
-            <a:ext cx="2971800" cy="458787"/>
-          </a:xfrm>
-          <a:prstGeom prst="rect">
-            <a:avLst/>
-          </a:prstGeom>
-        </p:spPr>
-        <p:txBody>
-          <a:bodyPr vert="horz" lIns="91440" tIns="45720" rIns="91440" bIns="45720" rtlCol="0" anchor="b"/>
-          <a:lstStyle>
-            <a:lvl1pPr algn="l">
-              <a:defRPr sz="1200"/>
-            </a:lvl1pPr>
-          </a:lstStyle>
-          <a:p>
-            <a:endParaRPr lang="en-US"/>
-          </a:p>
-        </p:txBody>
-      </p:sp>
-      <p:sp>
-        <p:nvSpPr>
-          <p:cNvPr id="7" name="Slide Number Placeholder 6"/>
-          <p:cNvSpPr>
-            <a:spLocks noGrp="1"/>
-          </p:cNvSpPr>
-          <p:nvPr>
-            <p:ph type="sldNum" sz="quarter" idx="5"/>
-          </p:nvPr>
-        </p:nvSpPr>
-        <p:spPr>
-          <a:xfrm>
-            <a:off x="3884613" y="8685213"/>
-            <a:ext cx="2971800" cy="458787"/>
-          </a:xfrm>
-          <a:prstGeom prst="rect">
-            <a:avLst/>
-          </a:prstGeom>
-        </p:spPr>
-        <p:txBody>
-          <a:bodyPr vert="horz" lIns="91440" tIns="45720" rIns="91440" bIns="45720" rtlCol="0" anchor="b"/>
-          <a:lstStyle>
-            <a:lvl1pPr algn="r">
-              <a:defRPr sz="1200"/>
-            </a:lvl1pPr>
-          </a:lstStyle>
-          <a:p>
-            <a:fld id="{CE5E9CC1-C706-0F49-92D6-E571CC5EEA8F}" type="slidenum">
-              <a:rPr lang="en-US"/>
-              <a:t>‹#›</a:t>
-            </a:fld>
-            <a:endParaRPr lang="en-US"/>
-          </a:p>
-        </p:txBody>
-      </p:sp>
     </p:spTree>
     <p:extLst>
       <p:ext uri="{BB962C8B-B14F-4D97-AF65-F5344CB8AC3E}">
-        <p14:creationId xmlns:p14="http://schemas.microsoft.com/office/powerpoint/2010/main" val="1024086991"/>
+        <p14:creationId xmlns:p14="http://schemas.microsoft.com/office/powerpoint/2010/main" val="434670290"/>
       </p:ext>
     </p:extLst>
   </p:cSld>
@@ -511,10 +329,6 @@
           <a:bodyPr/>
           <a:lstStyle/>
           <a:p>
-            <a:r>
-              <a:rPr lang="en-US" dirty="0"/>
-              <a:t/>
-            </a:r>
             <a:endParaRPr lang="en-US" dirty="0"/>
           </a:p>
         </p:txBody>
@@ -599,10 +413,6 @@
           <a:bodyPr/>
           <a:lstStyle/>
           <a:p>
-            <a:r>
-              <a:rPr lang="en-US" dirty="0"/>
-              <a:t/>
-            </a:r>
             <a:endParaRPr lang="en-US" dirty="0"/>
           </a:p>
         </p:txBody>
@@ -687,10 +497,6 @@
           <a:bodyPr/>
           <a:lstStyle/>
           <a:p>
-            <a:r>
-              <a:rPr lang="en-US" dirty="0"/>
-              <a:t/>
-            </a:r>
             <a:endParaRPr lang="en-US" dirty="0"/>
           </a:p>
         </p:txBody>
@@ -775,10 +581,6 @@
           <a:bodyPr/>
           <a:lstStyle/>
           <a:p>
-            <a:r>
-              <a:rPr lang="en-US" dirty="0"/>
-              <a:t/>
-            </a:r>
             <a:endParaRPr lang="en-US" dirty="0"/>
           </a:p>
         </p:txBody>
@@ -863,10 +665,6 @@
           <a:bodyPr/>
           <a:lstStyle/>
           <a:p>
-            <a:r>
-              <a:rPr lang="en-US" dirty="0"/>
-              <a:t/>
-            </a:r>
             <a:endParaRPr lang="en-US" dirty="0"/>
           </a:p>
         </p:txBody>
@@ -951,10 +749,6 @@
           <a:bodyPr/>
           <a:lstStyle/>
           <a:p>
-            <a:r>
-              <a:rPr lang="en-US" dirty="0"/>
-              <a:t/>
-            </a:r>
             <a:endParaRPr lang="en-US" dirty="0"/>
           </a:p>
         </p:txBody>
@@ -1039,10 +833,6 @@
           <a:bodyPr/>
           <a:lstStyle/>
           <a:p>
-            <a:r>
-              <a:rPr lang="en-US" dirty="0"/>
-              <a:t/>
-            </a:r>
             <a:endParaRPr lang="en-US" dirty="0"/>
           </a:p>
         </p:txBody>
@@ -1127,10 +917,6 @@
           <a:bodyPr/>
           <a:lstStyle/>
           <a:p>
-            <a:r>
-              <a:rPr lang="en-US" dirty="0"/>
-              <a:t/>
-            </a:r>
             <a:endParaRPr lang="en-US" dirty="0"/>
           </a:p>
         </p:txBody>
@@ -1215,10 +1001,6 @@
           <a:bodyPr/>
           <a:lstStyle/>
           <a:p>
-            <a:r>
-              <a:rPr lang="en-US" dirty="0"/>
-              <a:t/>
-            </a:r>
             <a:endParaRPr lang="en-US" dirty="0"/>
           </a:p>
         </p:txBody>
@@ -1303,10 +1085,6 @@
           <a:bodyPr/>
           <a:lstStyle/>
           <a:p>
-            <a:r>
-              <a:rPr lang="en-US" dirty="0"/>
-              <a:t/>
-            </a:r>
             <a:endParaRPr lang="en-US" dirty="0"/>
           </a:p>
         </p:txBody>
@@ -1391,10 +1169,6 @@
           <a:bodyPr/>
           <a:lstStyle/>
           <a:p>
-            <a:r>
-              <a:rPr lang="en-US" dirty="0"/>
-              <a:t/>
-            </a:r>
             <a:endParaRPr lang="en-US" dirty="0"/>
           </a:p>
         </p:txBody>
@@ -1479,10 +1253,6 @@
           <a:bodyPr/>
           <a:lstStyle/>
           <a:p>
-            <a:r>
-              <a:rPr lang="en-US" dirty="0"/>
-              <a:t/>
-            </a:r>
             <a:endParaRPr lang="en-US" dirty="0"/>
           </a:p>
         </p:txBody>
@@ -1556,6 +1326,11 @@
 <file path=ppt/slideMasters/slideMaster1.xml><?xml version="1.0" encoding="utf-8"?>
 <p:sldMaster xmlns:a="http://schemas.openxmlformats.org/drawingml/2006/main" xmlns:r="http://schemas.openxmlformats.org/officeDocument/2006/relationships" xmlns:p="http://schemas.openxmlformats.org/presentationml/2006/main">
   <p:cSld>
+    <p:bg>
+      <p:bgRef idx="1001">
+        <a:schemeClr val="bg1"/>
+      </p:bgRef>
+    </p:bg>
     <p:spTree>
       <p:nvGrpSpPr>
         <p:cNvPr id="1" name=""/>
@@ -1838,6 +1613,7 @@
         <a:solidFill>
           <a:srgbClr val="13233F"/>
         </a:solidFill>
+        <a:effectLst/>
       </p:bgPr>
     </p:bg>
     <p:spTree>
@@ -1875,6 +1651,13 @@
           </a:solidFill>
           <a:ln/>
         </p:spPr>
+        <p:txBody>
+          <a:bodyPr/>
+          <a:lstStyle/>
+          <a:p>
+            <a:endParaRPr lang="en-IN"/>
+          </a:p>
+        </p:txBody>
       </p:sp>
       <p:sp>
         <p:nvSpPr>
@@ -1897,6 +1680,13 @@
           </a:solidFill>
           <a:ln/>
         </p:spPr>
+        <p:txBody>
+          <a:bodyPr/>
+          <a:lstStyle/>
+          <a:p>
+            <a:endParaRPr lang="en-IN"/>
+          </a:p>
+        </p:txBody>
       </p:sp>
       <p:sp>
         <p:nvSpPr>
@@ -1917,6 +1707,13 @@
           </a:solidFill>
           <a:ln/>
         </p:spPr>
+        <p:txBody>
+          <a:bodyPr/>
+          <a:lstStyle/>
+          <a:p>
+            <a:endParaRPr lang="en-IN"/>
+          </a:p>
+        </p:txBody>
       </p:sp>
       <p:sp>
         <p:nvSpPr>
@@ -1939,7 +1736,7 @@
           <a:bodyPr wrap="square" rtlCol="0" anchor="ctr"/>
           <a:lstStyle/>
           <a:p>
-            <a:pPr algn="ctr" indent="0" marL="0">
+            <a:pPr marL="0" indent="0" algn="ctr">
               <a:buNone/>
             </a:pPr>
             <a:r>
@@ -1978,7 +1775,7 @@
           <a:bodyPr wrap="square" rtlCol="0" anchor="ctr"/>
           <a:lstStyle/>
           <a:p>
-            <a:pPr algn="ctr" indent="0" marL="0">
+            <a:pPr marL="0" indent="0" algn="ctr">
               <a:buNone/>
             </a:pPr>
             <a:r>
@@ -2017,7 +1814,7 @@
           <a:bodyPr wrap="square" rtlCol="0" anchor="ctr"/>
           <a:lstStyle/>
           <a:p>
-            <a:pPr algn="ctr" indent="0" marL="0">
+            <a:pPr marL="0" indent="0" algn="ctr">
               <a:buNone/>
             </a:pPr>
             <a:r>
@@ -2056,7 +1853,7 @@
           <a:bodyPr wrap="square" rtlCol="0" anchor="ctr"/>
           <a:lstStyle/>
           <a:p>
-            <a:pPr algn="ctr" indent="0" marL="0">
+            <a:pPr marL="0" indent="0" algn="ctr">
               <a:buNone/>
             </a:pPr>
             <a:r>
@@ -2096,6 +1893,13 @@
             <a:prstDash val="solid"/>
           </a:ln>
         </p:spPr>
+        <p:txBody>
+          <a:bodyPr/>
+          <a:lstStyle/>
+          <a:p>
+            <a:endParaRPr lang="en-IN"/>
+          </a:p>
+        </p:txBody>
       </p:sp>
       <p:sp>
         <p:nvSpPr>
@@ -2118,11 +1922,11 @@
           <a:bodyPr wrap="square" rtlCol="0" anchor="ctr"/>
           <a:lstStyle/>
           <a:p>
-            <a:pPr algn="ctr" indent="0" marL="0">
+            <a:pPr marL="0" indent="0" algn="ctr">
               <a:buNone/>
             </a:pPr>
             <a:r>
-              <a:rPr lang="en-US" sz="1300" b="1" dirty="0">
+              <a:rPr lang="en-US" sz="1300" b="1">
                 <a:solidFill>
                   <a:srgbClr val="FFFFFF"/>
                 </a:solidFill>
@@ -2130,11 +1934,8 @@
                 <a:ea typeface="Calibri" pitchFamily="34" charset="-122"/>
                 <a:cs typeface="Calibri" pitchFamily="34" charset="-120"/>
               </a:rPr>
-              <a:t>Team Members: </a:t>
-            </a:r>
-            <a:pPr algn="ctr" indent="0" marL="0">
-              <a:buNone/>
-            </a:pPr>
+              <a:t>NAME: </a:t>
+            </a:r>
             <a:r>
               <a:rPr lang="en-US" sz="1300" dirty="0">
                 <a:solidFill>
@@ -2144,7 +1945,7 @@
                 <a:ea typeface="Calibri" pitchFamily="34" charset="-122"/>
                 <a:cs typeface="Calibri" pitchFamily="34" charset="-120"/>
               </a:rPr>
-              <a:t>&lt;Your Name&gt;, &lt;Teammate 2&gt;, &lt;Teammate 3&gt;</a:t>
+              <a:t>HARSH KUMAR CHAUHAN</a:t>
             </a:r>
             <a:endParaRPr lang="en-US" sz="1300" dirty="0"/>
           </a:p>
@@ -2171,34 +1972,9 @@
           <a:bodyPr wrap="square" rtlCol="0" anchor="ctr"/>
           <a:lstStyle/>
           <a:p>
-            <a:pPr algn="ctr" indent="0" marL="0">
+            <a:pPr marL="0" indent="0" algn="ctr">
               <a:buNone/>
             </a:pPr>
-            <a:r>
-              <a:rPr lang="en-US" sz="1300" b="1" dirty="0">
-                <a:solidFill>
-                  <a:srgbClr val="FFFFFF"/>
-                </a:solidFill>
-                <a:latin typeface="Calibri" pitchFamily="34" charset="0"/>
-                <a:ea typeface="Calibri" pitchFamily="34" charset="-122"/>
-                <a:cs typeface="Calibri" pitchFamily="34" charset="-120"/>
-              </a:rPr>
-              <a:t>Guide: </a:t>
-            </a:r>
-            <a:pPr algn="ctr" indent="0" marL="0">
-              <a:buNone/>
-            </a:pPr>
-            <a:r>
-              <a:rPr lang="en-US" sz="1300" dirty="0">
-                <a:solidFill>
-                  <a:srgbClr val="CBD8EE"/>
-                </a:solidFill>
-                <a:latin typeface="Calibri" pitchFamily="34" charset="0"/>
-                <a:ea typeface="Calibri" pitchFamily="34" charset="-122"/>
-                <a:cs typeface="Calibri" pitchFamily="34" charset="-120"/>
-              </a:rPr>
-              <a:t>&lt;Faculty / Guide Name&gt;</a:t>
-            </a:r>
             <a:endParaRPr lang="en-US" sz="1300" dirty="0"/>
           </a:p>
         </p:txBody>
@@ -2219,6 +1995,7 @@
         <a:solidFill>
           <a:srgbClr val="F7F9FC"/>
         </a:solidFill>
+        <a:effectLst/>
       </p:bgPr>
     </p:bg>
     <p:spTree>
@@ -2256,7 +2033,7 @@
           <a:bodyPr wrap="square" rtlCol="0" anchor="ctr"/>
           <a:lstStyle/>
           <a:p>
-            <a:pPr indent="0" marL="0">
+            <a:pPr marL="0" indent="0">
               <a:buNone/>
             </a:pPr>
             <a:r>
@@ -2295,6 +2072,13 @@
           </a:solidFill>
           <a:ln/>
         </p:spPr>
+        <p:txBody>
+          <a:bodyPr/>
+          <a:lstStyle/>
+          <a:p>
+            <a:endParaRPr lang="en-IN"/>
+          </a:p>
+        </p:txBody>
       </p:sp>
       <p:sp>
         <p:nvSpPr>
@@ -2317,7 +2101,7 @@
           <a:bodyPr wrap="square" rtlCol="0" anchor="ctr"/>
           <a:lstStyle/>
           <a:p>
-            <a:pPr indent="0" marL="0">
+            <a:pPr marL="0" indent="0">
               <a:buNone/>
             </a:pPr>
             <a:r>
@@ -2334,7 +2118,7 @@
             <a:endParaRPr lang="en-US" sz="1150" dirty="0"/>
           </a:p>
           <a:p>
-            <a:pPr indent="0" marL="0">
+            <a:pPr marL="0" indent="0">
               <a:buNone/>
             </a:pPr>
             <a:r>
@@ -2351,7 +2135,7 @@
             <a:endParaRPr lang="en-US" sz="1150" dirty="0"/>
           </a:p>
           <a:p>
-            <a:pPr indent="0" marL="0">
+            <a:pPr marL="0" indent="0">
               <a:buNone/>
             </a:pPr>
             <a:r>
@@ -2368,7 +2152,7 @@
             <a:endParaRPr lang="en-US" sz="1150" dirty="0"/>
           </a:p>
           <a:p>
-            <a:pPr indent="0" marL="0">
+            <a:pPr marL="0" indent="0">
               <a:buNone/>
             </a:pPr>
             <a:r>
@@ -2385,7 +2169,7 @@
             <a:endParaRPr lang="en-US" sz="1150" dirty="0"/>
           </a:p>
           <a:p>
-            <a:pPr indent="0" marL="0">
+            <a:pPr marL="0" indent="0">
               <a:buNone/>
             </a:pPr>
             <a:r>
@@ -2402,7 +2186,7 @@
             <a:endParaRPr lang="en-US" sz="1150" dirty="0"/>
           </a:p>
           <a:p>
-            <a:pPr indent="0" marL="0">
+            <a:pPr marL="0" indent="0">
               <a:buNone/>
             </a:pPr>
             <a:r>
@@ -2419,7 +2203,7 @@
             <a:endParaRPr lang="en-US" sz="1150" dirty="0"/>
           </a:p>
           <a:p>
-            <a:pPr indent="0" marL="0">
+            <a:pPr marL="0" indent="0">
               <a:buNone/>
             </a:pPr>
             <a:r>
@@ -2436,7 +2220,7 @@
             <a:endParaRPr lang="en-US" sz="1150" dirty="0"/>
           </a:p>
           <a:p>
-            <a:pPr indent="0" marL="0">
+            <a:pPr marL="0" indent="0">
               <a:buNone/>
             </a:pPr>
             <a:r>
@@ -2453,7 +2237,7 @@
             <a:endParaRPr lang="en-US" sz="1150" dirty="0"/>
           </a:p>
           <a:p>
-            <a:pPr indent="0" marL="0">
+            <a:pPr marL="0" indent="0">
               <a:buNone/>
             </a:pPr>
             <a:r>
@@ -2470,7 +2254,7 @@
             <a:endParaRPr lang="en-US" sz="1150" dirty="0"/>
           </a:p>
           <a:p>
-            <a:pPr indent="0" marL="0">
+            <a:pPr marL="0" indent="0">
               <a:buNone/>
             </a:pPr>
             <a:r>
@@ -2487,7 +2271,7 @@
             <a:endParaRPr lang="en-US" sz="1150" dirty="0"/>
           </a:p>
           <a:p>
-            <a:pPr indent="0" marL="0">
+            <a:pPr marL="0" indent="0">
               <a:buNone/>
             </a:pPr>
             <a:r>
@@ -2504,7 +2288,7 @@
             <a:endParaRPr lang="en-US" sz="1150" dirty="0"/>
           </a:p>
           <a:p>
-            <a:pPr indent="0" marL="0">
+            <a:pPr marL="0" indent="0">
               <a:buNone/>
             </a:pPr>
             <a:r>
@@ -2521,7 +2305,7 @@
             <a:endParaRPr lang="en-US" sz="1150" dirty="0"/>
           </a:p>
           <a:p>
-            <a:pPr indent="0" marL="0">
+            <a:pPr marL="0" indent="0">
               <a:buNone/>
             </a:pPr>
             <a:r>
@@ -2538,7 +2322,7 @@
             <a:endParaRPr lang="en-US" sz="1150" dirty="0"/>
           </a:p>
           <a:p>
-            <a:pPr indent="0" marL="0">
+            <a:pPr marL="0" indent="0">
               <a:buNone/>
             </a:pPr>
             <a:r>
@@ -2555,7 +2339,7 @@
             <a:endParaRPr lang="en-US" sz="1150" dirty="0"/>
           </a:p>
           <a:p>
-            <a:pPr indent="0" marL="0">
+            <a:pPr marL="0" indent="0">
               <a:buNone/>
             </a:pPr>
             <a:r>
@@ -2572,7 +2356,7 @@
             <a:endParaRPr lang="en-US" sz="1150" dirty="0"/>
           </a:p>
           <a:p>
-            <a:pPr indent="0" marL="0">
+            <a:pPr marL="0" indent="0">
               <a:buNone/>
             </a:pPr>
             <a:r>
@@ -2589,7 +2373,7 @@
             <a:endParaRPr lang="en-US" sz="1150" dirty="0"/>
           </a:p>
           <a:p>
-            <a:pPr indent="0" marL="0">
+            <a:pPr marL="0" indent="0">
               <a:buNone/>
             </a:pPr>
             <a:r>
@@ -2626,6 +2410,13 @@
           </a:solidFill>
           <a:ln/>
         </p:spPr>
+        <p:txBody>
+          <a:bodyPr/>
+          <a:lstStyle/>
+          <a:p>
+            <a:endParaRPr lang="en-IN"/>
+          </a:p>
+        </p:txBody>
       </p:sp>
       <p:sp>
         <p:nvSpPr>
@@ -2648,7 +2439,7 @@
           <a:bodyPr wrap="square" rtlCol="0" anchor="ctr"/>
           <a:lstStyle/>
           <a:p>
-            <a:pPr algn="ctr" indent="0" marL="0">
+            <a:pPr marL="0" indent="0" algn="ctr">
               <a:buNone/>
             </a:pPr>
             <a:r>
@@ -2687,7 +2478,7 @@
           <a:bodyPr wrap="square" rtlCol="0" anchor="ctr"/>
           <a:lstStyle/>
           <a:p>
-            <a:pPr indent="0" marL="0">
+            <a:pPr marL="0" indent="0">
               <a:buNone/>
             </a:pPr>
             <a:r>
@@ -2724,6 +2515,13 @@
           </a:solidFill>
           <a:ln/>
         </p:spPr>
+        <p:txBody>
+          <a:bodyPr/>
+          <a:lstStyle/>
+          <a:p>
+            <a:endParaRPr lang="en-IN"/>
+          </a:p>
+        </p:txBody>
       </p:sp>
       <p:sp>
         <p:nvSpPr>
@@ -2746,7 +2544,7 @@
           <a:bodyPr wrap="square" rtlCol="0" anchor="ctr"/>
           <a:lstStyle/>
           <a:p>
-            <a:pPr algn="ctr" indent="0" marL="0">
+            <a:pPr marL="0" indent="0" algn="ctr">
               <a:buNone/>
             </a:pPr>
             <a:r>
@@ -2785,7 +2583,7 @@
           <a:bodyPr wrap="square" rtlCol="0" anchor="ctr"/>
           <a:lstStyle/>
           <a:p>
-            <a:pPr indent="0" marL="0">
+            <a:pPr marL="0" indent="0">
               <a:buNone/>
             </a:pPr>
             <a:r>
@@ -2822,6 +2620,13 @@
           </a:solidFill>
           <a:ln/>
         </p:spPr>
+        <p:txBody>
+          <a:bodyPr/>
+          <a:lstStyle/>
+          <a:p>
+            <a:endParaRPr lang="en-IN"/>
+          </a:p>
+        </p:txBody>
       </p:sp>
       <p:sp>
         <p:nvSpPr>
@@ -2844,7 +2649,7 @@
           <a:bodyPr wrap="square" rtlCol="0" anchor="ctr"/>
           <a:lstStyle/>
           <a:p>
-            <a:pPr algn="ctr" indent="0" marL="0">
+            <a:pPr marL="0" indent="0" algn="ctr">
               <a:buNone/>
             </a:pPr>
             <a:r>
@@ -2883,7 +2688,7 @@
           <a:bodyPr wrap="square" rtlCol="0" anchor="ctr"/>
           <a:lstStyle/>
           <a:p>
-            <a:pPr indent="0" marL="0">
+            <a:pPr marL="0" indent="0">
               <a:buNone/>
             </a:pPr>
             <a:r>
@@ -2920,6 +2725,13 @@
           </a:solidFill>
           <a:ln/>
         </p:spPr>
+        <p:txBody>
+          <a:bodyPr/>
+          <a:lstStyle/>
+          <a:p>
+            <a:endParaRPr lang="en-IN"/>
+          </a:p>
+        </p:txBody>
       </p:sp>
       <p:sp>
         <p:nvSpPr>
@@ -2942,7 +2754,7 @@
           <a:bodyPr wrap="square" rtlCol="0" anchor="ctr"/>
           <a:lstStyle/>
           <a:p>
-            <a:pPr algn="ctr" indent="0" marL="0">
+            <a:pPr marL="0" indent="0" algn="ctr">
               <a:buNone/>
             </a:pPr>
             <a:r>
@@ -2981,7 +2793,7 @@
           <a:bodyPr wrap="square" rtlCol="0" anchor="ctr"/>
           <a:lstStyle/>
           <a:p>
-            <a:pPr indent="0" marL="0">
+            <a:pPr marL="0" indent="0">
               <a:buNone/>
             </a:pPr>
             <a:r>
@@ -3020,7 +2832,7 @@
           <a:bodyPr wrap="square" rtlCol="0" anchor="ctr"/>
           <a:lstStyle/>
           <a:p>
-            <a:pPr indent="0" marL="0">
+            <a:pPr marL="0" indent="0">
               <a:buNone/>
             </a:pPr>
             <a:r>
@@ -3059,7 +2871,7 @@
           <a:bodyPr wrap="square" rtlCol="0" anchor="ctr"/>
           <a:lstStyle/>
           <a:p>
-            <a:pPr algn="r" indent="0" marL="0">
+            <a:pPr marL="0" indent="0" algn="r">
               <a:buNone/>
             </a:pPr>
             <a:r>
@@ -3093,6 +2905,7 @@
         <a:solidFill>
           <a:srgbClr val="13233F"/>
         </a:solidFill>
+        <a:effectLst/>
       </p:bgPr>
     </p:bg>
     <p:spTree>
@@ -3130,7 +2943,7 @@
           <a:bodyPr wrap="square" rtlCol="0" anchor="ctr"/>
           <a:lstStyle/>
           <a:p>
-            <a:pPr indent="0" marL="0">
+            <a:pPr marL="0" indent="0">
               <a:buNone/>
             </a:pPr>
             <a:r>
@@ -3169,6 +2982,13 @@
           </a:solidFill>
           <a:ln/>
         </p:spPr>
+        <p:txBody>
+          <a:bodyPr/>
+          <a:lstStyle/>
+          <a:p>
+            <a:endParaRPr lang="en-IN"/>
+          </a:p>
+        </p:txBody>
       </p:sp>
       <p:sp>
         <p:nvSpPr>
@@ -3189,6 +3009,13 @@
           </a:solidFill>
           <a:ln/>
         </p:spPr>
+        <p:txBody>
+          <a:bodyPr/>
+          <a:lstStyle/>
+          <a:p>
+            <a:endParaRPr lang="en-IN"/>
+          </a:p>
+        </p:txBody>
       </p:sp>
       <p:sp>
         <p:nvSpPr>
@@ -3211,7 +3038,7 @@
           <a:bodyPr wrap="square" rtlCol="0" anchor="ctr"/>
           <a:lstStyle/>
           <a:p>
-            <a:pPr algn="ctr" indent="0" marL="0">
+            <a:pPr marL="0" indent="0" algn="ctr">
               <a:buNone/>
             </a:pPr>
             <a:r>
@@ -3250,7 +3077,7 @@
           <a:bodyPr wrap="square" rtlCol="0" anchor="ctr"/>
           <a:lstStyle/>
           <a:p>
-            <a:pPr indent="0" marL="0">
+            <a:pPr marL="0" indent="0">
               <a:lnSpc>
                 <a:spcPct val="110000"/>
               </a:lnSpc>
@@ -3292,6 +3119,13 @@
           </a:solidFill>
           <a:ln/>
         </p:spPr>
+        <p:txBody>
+          <a:bodyPr/>
+          <a:lstStyle/>
+          <a:p>
+            <a:endParaRPr lang="en-IN"/>
+          </a:p>
+        </p:txBody>
       </p:sp>
       <p:sp>
         <p:nvSpPr>
@@ -3312,6 +3146,13 @@
           </a:solidFill>
           <a:ln/>
         </p:spPr>
+        <p:txBody>
+          <a:bodyPr/>
+          <a:lstStyle/>
+          <a:p>
+            <a:endParaRPr lang="en-IN"/>
+          </a:p>
+        </p:txBody>
       </p:sp>
       <p:sp>
         <p:nvSpPr>
@@ -3334,7 +3175,7 @@
           <a:bodyPr wrap="square" rtlCol="0" anchor="ctr"/>
           <a:lstStyle/>
           <a:p>
-            <a:pPr algn="ctr" indent="0" marL="0">
+            <a:pPr marL="0" indent="0" algn="ctr">
               <a:buNone/>
             </a:pPr>
             <a:r>
@@ -3373,7 +3214,7 @@
           <a:bodyPr wrap="square" rtlCol="0" anchor="ctr"/>
           <a:lstStyle/>
           <a:p>
-            <a:pPr indent="0" marL="0">
+            <a:pPr marL="0" indent="0">
               <a:lnSpc>
                 <a:spcPct val="110000"/>
               </a:lnSpc>
@@ -3415,6 +3256,13 @@
           </a:solidFill>
           <a:ln/>
         </p:spPr>
+        <p:txBody>
+          <a:bodyPr/>
+          <a:lstStyle/>
+          <a:p>
+            <a:endParaRPr lang="en-IN"/>
+          </a:p>
+        </p:txBody>
       </p:sp>
       <p:sp>
         <p:nvSpPr>
@@ -3435,6 +3283,13 @@
           </a:solidFill>
           <a:ln/>
         </p:spPr>
+        <p:txBody>
+          <a:bodyPr/>
+          <a:lstStyle/>
+          <a:p>
+            <a:endParaRPr lang="en-IN"/>
+          </a:p>
+        </p:txBody>
       </p:sp>
       <p:sp>
         <p:nvSpPr>
@@ -3457,7 +3312,7 @@
           <a:bodyPr wrap="square" rtlCol="0" anchor="ctr"/>
           <a:lstStyle/>
           <a:p>
-            <a:pPr algn="ctr" indent="0" marL="0">
+            <a:pPr marL="0" indent="0" algn="ctr">
               <a:buNone/>
             </a:pPr>
             <a:r>
@@ -3496,7 +3351,7 @@
           <a:bodyPr wrap="square" rtlCol="0" anchor="ctr"/>
           <a:lstStyle/>
           <a:p>
-            <a:pPr indent="0" marL="0">
+            <a:pPr marL="0" indent="0">
               <a:lnSpc>
                 <a:spcPct val="110000"/>
               </a:lnSpc>
@@ -3538,6 +3393,13 @@
           </a:solidFill>
           <a:ln/>
         </p:spPr>
+        <p:txBody>
+          <a:bodyPr/>
+          <a:lstStyle/>
+          <a:p>
+            <a:endParaRPr lang="en-IN"/>
+          </a:p>
+        </p:txBody>
       </p:sp>
       <p:sp>
         <p:nvSpPr>
@@ -3558,6 +3420,13 @@
           </a:solidFill>
           <a:ln/>
         </p:spPr>
+        <p:txBody>
+          <a:bodyPr/>
+          <a:lstStyle/>
+          <a:p>
+            <a:endParaRPr lang="en-IN"/>
+          </a:p>
+        </p:txBody>
       </p:sp>
       <p:sp>
         <p:nvSpPr>
@@ -3580,7 +3449,7 @@
           <a:bodyPr wrap="square" rtlCol="0" anchor="ctr"/>
           <a:lstStyle/>
           <a:p>
-            <a:pPr algn="ctr" indent="0" marL="0">
+            <a:pPr marL="0" indent="0" algn="ctr">
               <a:buNone/>
             </a:pPr>
             <a:r>
@@ -3619,7 +3488,7 @@
           <a:bodyPr wrap="square" rtlCol="0" anchor="ctr"/>
           <a:lstStyle/>
           <a:p>
-            <a:pPr indent="0" marL="0">
+            <a:pPr marL="0" indent="0">
               <a:lnSpc>
                 <a:spcPct val="110000"/>
               </a:lnSpc>
@@ -3661,6 +3530,13 @@
           </a:solidFill>
           <a:ln/>
         </p:spPr>
+        <p:txBody>
+          <a:bodyPr/>
+          <a:lstStyle/>
+          <a:p>
+            <a:endParaRPr lang="en-IN"/>
+          </a:p>
+        </p:txBody>
       </p:sp>
       <p:sp>
         <p:nvSpPr>
@@ -3681,6 +3557,13 @@
           </a:solidFill>
           <a:ln/>
         </p:spPr>
+        <p:txBody>
+          <a:bodyPr/>
+          <a:lstStyle/>
+          <a:p>
+            <a:endParaRPr lang="en-IN"/>
+          </a:p>
+        </p:txBody>
       </p:sp>
       <p:sp>
         <p:nvSpPr>
@@ -3703,7 +3586,7 @@
           <a:bodyPr wrap="square" rtlCol="0" anchor="ctr"/>
           <a:lstStyle/>
           <a:p>
-            <a:pPr algn="ctr" indent="0" marL="0">
+            <a:pPr marL="0" indent="0" algn="ctr">
               <a:buNone/>
             </a:pPr>
             <a:r>
@@ -3742,7 +3625,7 @@
           <a:bodyPr wrap="square" rtlCol="0" anchor="ctr"/>
           <a:lstStyle/>
           <a:p>
-            <a:pPr indent="0" marL="0">
+            <a:pPr marL="0" indent="0">
               <a:lnSpc>
                 <a:spcPct val="110000"/>
               </a:lnSpc>
@@ -3784,6 +3667,13 @@
           </a:solidFill>
           <a:ln/>
         </p:spPr>
+        <p:txBody>
+          <a:bodyPr/>
+          <a:lstStyle/>
+          <a:p>
+            <a:endParaRPr lang="en-IN"/>
+          </a:p>
+        </p:txBody>
       </p:sp>
       <p:sp>
         <p:nvSpPr>
@@ -3804,6 +3694,13 @@
           </a:solidFill>
           <a:ln/>
         </p:spPr>
+        <p:txBody>
+          <a:bodyPr/>
+          <a:lstStyle/>
+          <a:p>
+            <a:endParaRPr lang="en-IN"/>
+          </a:p>
+        </p:txBody>
       </p:sp>
       <p:sp>
         <p:nvSpPr>
@@ -3826,7 +3723,7 @@
           <a:bodyPr wrap="square" rtlCol="0" anchor="ctr"/>
           <a:lstStyle/>
           <a:p>
-            <a:pPr algn="ctr" indent="0" marL="0">
+            <a:pPr marL="0" indent="0" algn="ctr">
               <a:buNone/>
             </a:pPr>
             <a:r>
@@ -3865,7 +3762,7 @@
           <a:bodyPr wrap="square" rtlCol="0" anchor="ctr"/>
           <a:lstStyle/>
           <a:p>
-            <a:pPr indent="0" marL="0">
+            <a:pPr marL="0" indent="0">
               <a:lnSpc>
                 <a:spcPct val="110000"/>
               </a:lnSpc>
@@ -3907,7 +3804,7 @@
           <a:bodyPr wrap="square" rtlCol="0" anchor="ctr"/>
           <a:lstStyle/>
           <a:p>
-            <a:pPr indent="0" marL="0">
+            <a:pPr marL="0" indent="0">
               <a:buNone/>
             </a:pPr>
             <a:r>
@@ -3946,7 +3843,7 @@
           <a:bodyPr wrap="square" rtlCol="0" anchor="ctr"/>
           <a:lstStyle/>
           <a:p>
-            <a:pPr algn="r" indent="0" marL="0">
+            <a:pPr marL="0" indent="0" algn="r">
               <a:buNone/>
             </a:pPr>
             <a:r>
@@ -3980,6 +3877,7 @@
         <a:solidFill>
           <a:srgbClr val="13233F"/>
         </a:solidFill>
+        <a:effectLst/>
       </p:bgPr>
     </p:bg>
     <p:spTree>
@@ -4017,6 +3915,13 @@
           </a:solidFill>
           <a:ln/>
         </p:spPr>
+        <p:txBody>
+          <a:bodyPr/>
+          <a:lstStyle/>
+          <a:p>
+            <a:endParaRPr lang="en-IN"/>
+          </a:p>
+        </p:txBody>
       </p:sp>
       <p:sp>
         <p:nvSpPr>
@@ -4039,6 +3944,13 @@
           </a:solidFill>
           <a:ln/>
         </p:spPr>
+        <p:txBody>
+          <a:bodyPr/>
+          <a:lstStyle/>
+          <a:p>
+            <a:endParaRPr lang="en-IN"/>
+          </a:p>
+        </p:txBody>
       </p:sp>
       <p:sp>
         <p:nvSpPr>
@@ -4061,7 +3973,7 @@
           <a:bodyPr wrap="square" rtlCol="0" anchor="ctr"/>
           <a:lstStyle/>
           <a:p>
-            <a:pPr algn="ctr" indent="0" marL="0">
+            <a:pPr marL="0" indent="0" algn="ctr">
               <a:buNone/>
             </a:pPr>
             <a:r>
@@ -4101,6 +4013,13 @@
             <a:prstDash val="solid"/>
           </a:ln>
         </p:spPr>
+        <p:txBody>
+          <a:bodyPr/>
+          <a:lstStyle/>
+          <a:p>
+            <a:endParaRPr lang="en-IN"/>
+          </a:p>
+        </p:txBody>
       </p:sp>
       <p:sp>
         <p:nvSpPr>
@@ -4123,7 +4042,7 @@
           <a:bodyPr wrap="square" rtlCol="0" anchor="ctr"/>
           <a:lstStyle/>
           <a:p>
-            <a:pPr algn="ctr" indent="0" marL="0">
+            <a:pPr marL="0" indent="0" algn="ctr">
               <a:buNone/>
             </a:pPr>
             <a:r>
@@ -4157,6 +4076,7 @@
         <a:solidFill>
           <a:srgbClr val="F7F9FC"/>
         </a:solidFill>
+        <a:effectLst/>
       </p:bgPr>
     </p:bg>
     <p:spTree>
@@ -4194,7 +4114,7 @@
           <a:bodyPr wrap="square" rtlCol="0" anchor="ctr"/>
           <a:lstStyle/>
           <a:p>
-            <a:pPr indent="0" marL="0">
+            <a:pPr marL="0" indent="0">
               <a:buNone/>
             </a:pPr>
             <a:r>
@@ -4238,6 +4158,13 @@
             <a:prstDash val="solid"/>
           </a:ln>
         </p:spPr>
+        <p:txBody>
+          <a:bodyPr/>
+          <a:lstStyle/>
+          <a:p>
+            <a:endParaRPr lang="en-IN"/>
+          </a:p>
+        </p:txBody>
       </p:sp>
       <p:sp>
         <p:nvSpPr>
@@ -4258,6 +4185,13 @@
           </a:solidFill>
           <a:ln/>
         </p:spPr>
+        <p:txBody>
+          <a:bodyPr/>
+          <a:lstStyle/>
+          <a:p>
+            <a:endParaRPr lang="en-IN"/>
+          </a:p>
+        </p:txBody>
       </p:sp>
       <p:sp>
         <p:nvSpPr>
@@ -4280,7 +4214,7 @@
           <a:bodyPr wrap="square" rtlCol="0" anchor="ctr"/>
           <a:lstStyle/>
           <a:p>
-            <a:pPr algn="ctr" indent="0" marL="0">
+            <a:pPr marL="0" indent="0" algn="ctr">
               <a:buNone/>
             </a:pPr>
             <a:r>
@@ -4319,7 +4253,7 @@
           <a:bodyPr wrap="square" rtlCol="0" anchor="ctr"/>
           <a:lstStyle/>
           <a:p>
-            <a:pPr indent="0" marL="0">
+            <a:pPr marL="0" indent="0">
               <a:buNone/>
             </a:pPr>
             <a:r>
@@ -4358,7 +4292,7 @@
           <a:bodyPr wrap="square" rtlCol="0" anchor="ctr"/>
           <a:lstStyle/>
           <a:p>
-            <a:pPr indent="0" marL="0">
+            <a:pPr marL="0" indent="0">
               <a:lnSpc>
                 <a:spcPct val="125000"/>
               </a:lnSpc>
@@ -4400,7 +4334,7 @@
           <a:bodyPr wrap="square" rtlCol="0" anchor="ctr"/>
           <a:lstStyle/>
           <a:p>
-            <a:pPr indent="0" marL="0">
+            <a:pPr marL="0" indent="0">
               <a:buNone/>
             </a:pPr>
             <a:r>
@@ -4439,7 +4373,7 @@
           <a:bodyPr wrap="square" rtlCol="0" anchor="ctr"/>
           <a:lstStyle/>
           <a:p>
-            <a:pPr indent="0" marL="0">
+            <a:pPr marL="0" indent="0">
               <a:buNone/>
             </a:pPr>
             <a:r>
@@ -4478,6 +4412,13 @@
           </a:solidFill>
           <a:ln/>
         </p:spPr>
+        <p:txBody>
+          <a:bodyPr/>
+          <a:lstStyle/>
+          <a:p>
+            <a:endParaRPr lang="en-IN"/>
+          </a:p>
+        </p:txBody>
       </p:sp>
       <p:sp>
         <p:nvSpPr>
@@ -4498,6 +4439,13 @@
           </a:solidFill>
           <a:ln/>
         </p:spPr>
+        <p:txBody>
+          <a:bodyPr/>
+          <a:lstStyle/>
+          <a:p>
+            <a:endParaRPr lang="en-IN"/>
+          </a:p>
+        </p:txBody>
       </p:sp>
       <p:sp>
         <p:nvSpPr>
@@ -4520,7 +4468,7 @@
           <a:bodyPr wrap="square" rtlCol="0" anchor="ctr"/>
           <a:lstStyle/>
           <a:p>
-            <a:pPr algn="ctr" indent="0" marL="0">
+            <a:pPr marL="0" indent="0" algn="ctr">
               <a:buNone/>
             </a:pPr>
             <a:r>
@@ -4559,7 +4507,7 @@
           <a:bodyPr wrap="square" rtlCol="0" anchor="ctr"/>
           <a:lstStyle/>
           <a:p>
-            <a:pPr indent="0" marL="0">
+            <a:pPr marL="0" indent="0">
               <a:buNone/>
             </a:pPr>
             <a:r>
@@ -4598,7 +4546,7 @@
           <a:bodyPr wrap="square" rtlCol="0" anchor="ctr"/>
           <a:lstStyle/>
           <a:p>
-            <a:pPr indent="0" marL="0">
+            <a:pPr marL="0" indent="0">
               <a:lnSpc>
                 <a:spcPct val="125000"/>
               </a:lnSpc>
@@ -4640,7 +4588,7 @@
           <a:bodyPr wrap="square" rtlCol="0" anchor="ctr"/>
           <a:lstStyle/>
           <a:p>
-            <a:pPr indent="0" marL="0">
+            <a:pPr marL="0" indent="0">
               <a:buNone/>
             </a:pPr>
             <a:r>
@@ -4839,7 +4787,7 @@
           <a:bodyPr wrap="square" rtlCol="0" anchor="ctr"/>
           <a:lstStyle/>
           <a:p>
-            <a:pPr indent="0" marL="0">
+            <a:pPr marL="0" indent="0">
               <a:buNone/>
             </a:pPr>
             <a:r>
@@ -4878,7 +4826,7 @@
           <a:bodyPr wrap="square" rtlCol="0" anchor="ctr"/>
           <a:lstStyle/>
           <a:p>
-            <a:pPr algn="r" indent="0" marL="0">
+            <a:pPr marL="0" indent="0" algn="r">
               <a:buNone/>
             </a:pPr>
             <a:r>
@@ -4912,6 +4860,7 @@
         <a:solidFill>
           <a:srgbClr val="F7F9FC"/>
         </a:solidFill>
+        <a:effectLst/>
       </p:bgPr>
     </p:bg>
     <p:spTree>
@@ -4949,7 +4898,7 @@
           <a:bodyPr wrap="square" rtlCol="0" anchor="ctr"/>
           <a:lstStyle/>
           <a:p>
-            <a:pPr indent="0" marL="0">
+            <a:pPr marL="0" indent="0">
               <a:buNone/>
             </a:pPr>
             <a:r>
@@ -4993,6 +4942,13 @@
             <a:prstDash val="solid"/>
           </a:ln>
         </p:spPr>
+        <p:txBody>
+          <a:bodyPr/>
+          <a:lstStyle/>
+          <a:p>
+            <a:endParaRPr lang="en-IN"/>
+          </a:p>
+        </p:txBody>
       </p:sp>
       <p:sp>
         <p:nvSpPr>
@@ -5013,6 +4969,13 @@
           </a:solidFill>
           <a:ln/>
         </p:spPr>
+        <p:txBody>
+          <a:bodyPr/>
+          <a:lstStyle/>
+          <a:p>
+            <a:endParaRPr lang="en-IN"/>
+          </a:p>
+        </p:txBody>
       </p:sp>
       <p:sp>
         <p:nvSpPr>
@@ -5035,7 +4998,7 @@
           <a:bodyPr wrap="square" rtlCol="0" anchor="ctr"/>
           <a:lstStyle/>
           <a:p>
-            <a:pPr algn="ctr" indent="0" marL="0">
+            <a:pPr marL="0" indent="0" algn="ctr">
               <a:buNone/>
             </a:pPr>
             <a:r>
@@ -5074,7 +5037,7 @@
           <a:bodyPr wrap="square" rtlCol="0" anchor="ctr"/>
           <a:lstStyle/>
           <a:p>
-            <a:pPr indent="0" marL="0">
+            <a:pPr marL="0" indent="0">
               <a:lnSpc>
                 <a:spcPct val="110000"/>
               </a:lnSpc>
@@ -5121,6 +5084,13 @@
             <a:prstDash val="solid"/>
           </a:ln>
         </p:spPr>
+        <p:txBody>
+          <a:bodyPr/>
+          <a:lstStyle/>
+          <a:p>
+            <a:endParaRPr lang="en-IN"/>
+          </a:p>
+        </p:txBody>
       </p:sp>
       <p:sp>
         <p:nvSpPr>
@@ -5141,6 +5111,13 @@
           </a:solidFill>
           <a:ln/>
         </p:spPr>
+        <p:txBody>
+          <a:bodyPr/>
+          <a:lstStyle/>
+          <a:p>
+            <a:endParaRPr lang="en-IN"/>
+          </a:p>
+        </p:txBody>
       </p:sp>
       <p:sp>
         <p:nvSpPr>
@@ -5163,7 +5140,7 @@
           <a:bodyPr wrap="square" rtlCol="0" anchor="ctr"/>
           <a:lstStyle/>
           <a:p>
-            <a:pPr algn="ctr" indent="0" marL="0">
+            <a:pPr marL="0" indent="0" algn="ctr">
               <a:buNone/>
             </a:pPr>
             <a:r>
@@ -5202,7 +5179,7 @@
           <a:bodyPr wrap="square" rtlCol="0" anchor="ctr"/>
           <a:lstStyle/>
           <a:p>
-            <a:pPr indent="0" marL="0">
+            <a:pPr marL="0" indent="0">
               <a:lnSpc>
                 <a:spcPct val="110000"/>
               </a:lnSpc>
@@ -5249,6 +5226,13 @@
             <a:prstDash val="solid"/>
           </a:ln>
         </p:spPr>
+        <p:txBody>
+          <a:bodyPr/>
+          <a:lstStyle/>
+          <a:p>
+            <a:endParaRPr lang="en-IN"/>
+          </a:p>
+        </p:txBody>
       </p:sp>
       <p:sp>
         <p:nvSpPr>
@@ -5269,6 +5253,13 @@
           </a:solidFill>
           <a:ln/>
         </p:spPr>
+        <p:txBody>
+          <a:bodyPr/>
+          <a:lstStyle/>
+          <a:p>
+            <a:endParaRPr lang="en-IN"/>
+          </a:p>
+        </p:txBody>
       </p:sp>
       <p:sp>
         <p:nvSpPr>
@@ -5291,7 +5282,7 @@
           <a:bodyPr wrap="square" rtlCol="0" anchor="ctr"/>
           <a:lstStyle/>
           <a:p>
-            <a:pPr algn="ctr" indent="0" marL="0">
+            <a:pPr marL="0" indent="0" algn="ctr">
               <a:buNone/>
             </a:pPr>
             <a:r>
@@ -5330,7 +5321,7 @@
           <a:bodyPr wrap="square" rtlCol="0" anchor="ctr"/>
           <a:lstStyle/>
           <a:p>
-            <a:pPr indent="0" marL="0">
+            <a:pPr marL="0" indent="0">
               <a:lnSpc>
                 <a:spcPct val="110000"/>
               </a:lnSpc>
@@ -5377,6 +5368,13 @@
             <a:prstDash val="solid"/>
           </a:ln>
         </p:spPr>
+        <p:txBody>
+          <a:bodyPr/>
+          <a:lstStyle/>
+          <a:p>
+            <a:endParaRPr lang="en-IN"/>
+          </a:p>
+        </p:txBody>
       </p:sp>
       <p:sp>
         <p:nvSpPr>
@@ -5397,6 +5395,13 @@
           </a:solidFill>
           <a:ln/>
         </p:spPr>
+        <p:txBody>
+          <a:bodyPr/>
+          <a:lstStyle/>
+          <a:p>
+            <a:endParaRPr lang="en-IN"/>
+          </a:p>
+        </p:txBody>
       </p:sp>
       <p:sp>
         <p:nvSpPr>
@@ -5419,7 +5424,7 @@
           <a:bodyPr wrap="square" rtlCol="0" anchor="ctr"/>
           <a:lstStyle/>
           <a:p>
-            <a:pPr algn="ctr" indent="0" marL="0">
+            <a:pPr marL="0" indent="0" algn="ctr">
               <a:buNone/>
             </a:pPr>
             <a:r>
@@ -5458,7 +5463,7 @@
           <a:bodyPr wrap="square" rtlCol="0" anchor="ctr"/>
           <a:lstStyle/>
           <a:p>
-            <a:pPr indent="0" marL="0">
+            <a:pPr marL="0" indent="0">
               <a:lnSpc>
                 <a:spcPct val="110000"/>
               </a:lnSpc>
@@ -5505,6 +5510,13 @@
             <a:prstDash val="solid"/>
           </a:ln>
         </p:spPr>
+        <p:txBody>
+          <a:bodyPr/>
+          <a:lstStyle/>
+          <a:p>
+            <a:endParaRPr lang="en-IN"/>
+          </a:p>
+        </p:txBody>
       </p:sp>
       <p:sp>
         <p:nvSpPr>
@@ -5525,6 +5537,13 @@
           </a:solidFill>
           <a:ln/>
         </p:spPr>
+        <p:txBody>
+          <a:bodyPr/>
+          <a:lstStyle/>
+          <a:p>
+            <a:endParaRPr lang="en-IN"/>
+          </a:p>
+        </p:txBody>
       </p:sp>
       <p:sp>
         <p:nvSpPr>
@@ -5547,7 +5566,7 @@
           <a:bodyPr wrap="square" rtlCol="0" anchor="ctr"/>
           <a:lstStyle/>
           <a:p>
-            <a:pPr algn="ctr" indent="0" marL="0">
+            <a:pPr marL="0" indent="0" algn="ctr">
               <a:buNone/>
             </a:pPr>
             <a:r>
@@ -5586,7 +5605,7 @@
           <a:bodyPr wrap="square" rtlCol="0" anchor="ctr"/>
           <a:lstStyle/>
           <a:p>
-            <a:pPr indent="0" marL="0">
+            <a:pPr marL="0" indent="0">
               <a:lnSpc>
                 <a:spcPct val="110000"/>
               </a:lnSpc>
@@ -5633,6 +5652,13 @@
             <a:prstDash val="solid"/>
           </a:ln>
         </p:spPr>
+        <p:txBody>
+          <a:bodyPr/>
+          <a:lstStyle/>
+          <a:p>
+            <a:endParaRPr lang="en-IN"/>
+          </a:p>
+        </p:txBody>
       </p:sp>
       <p:sp>
         <p:nvSpPr>
@@ -5653,6 +5679,13 @@
           </a:solidFill>
           <a:ln/>
         </p:spPr>
+        <p:txBody>
+          <a:bodyPr/>
+          <a:lstStyle/>
+          <a:p>
+            <a:endParaRPr lang="en-IN"/>
+          </a:p>
+        </p:txBody>
       </p:sp>
       <p:sp>
         <p:nvSpPr>
@@ -5675,7 +5708,7 @@
           <a:bodyPr wrap="square" rtlCol="0" anchor="ctr"/>
           <a:lstStyle/>
           <a:p>
-            <a:pPr algn="ctr" indent="0" marL="0">
+            <a:pPr marL="0" indent="0" algn="ctr">
               <a:buNone/>
             </a:pPr>
             <a:r>
@@ -5714,7 +5747,7 @@
           <a:bodyPr wrap="square" rtlCol="0" anchor="ctr"/>
           <a:lstStyle/>
           <a:p>
-            <a:pPr indent="0" marL="0">
+            <a:pPr marL="0" indent="0">
               <a:lnSpc>
                 <a:spcPct val="110000"/>
               </a:lnSpc>
@@ -5761,6 +5794,13 @@
             <a:prstDash val="solid"/>
           </a:ln>
         </p:spPr>
+        <p:txBody>
+          <a:bodyPr/>
+          <a:lstStyle/>
+          <a:p>
+            <a:endParaRPr lang="en-IN"/>
+          </a:p>
+        </p:txBody>
       </p:sp>
       <p:sp>
         <p:nvSpPr>
@@ -5781,6 +5821,13 @@
           </a:solidFill>
           <a:ln/>
         </p:spPr>
+        <p:txBody>
+          <a:bodyPr/>
+          <a:lstStyle/>
+          <a:p>
+            <a:endParaRPr lang="en-IN"/>
+          </a:p>
+        </p:txBody>
       </p:sp>
       <p:sp>
         <p:nvSpPr>
@@ -5803,7 +5850,7 @@
           <a:bodyPr wrap="square" rtlCol="0" anchor="ctr"/>
           <a:lstStyle/>
           <a:p>
-            <a:pPr algn="ctr" indent="0" marL="0">
+            <a:pPr marL="0" indent="0" algn="ctr">
               <a:buNone/>
             </a:pPr>
             <a:r>
@@ -5842,7 +5889,7 @@
           <a:bodyPr wrap="square" rtlCol="0" anchor="ctr"/>
           <a:lstStyle/>
           <a:p>
-            <a:pPr indent="0" marL="0">
+            <a:pPr marL="0" indent="0">
               <a:lnSpc>
                 <a:spcPct val="110000"/>
               </a:lnSpc>
@@ -5889,6 +5936,13 @@
             <a:prstDash val="solid"/>
           </a:ln>
         </p:spPr>
+        <p:txBody>
+          <a:bodyPr/>
+          <a:lstStyle/>
+          <a:p>
+            <a:endParaRPr lang="en-IN"/>
+          </a:p>
+        </p:txBody>
       </p:sp>
       <p:sp>
         <p:nvSpPr>
@@ -5909,6 +5963,13 @@
           </a:solidFill>
           <a:ln/>
         </p:spPr>
+        <p:txBody>
+          <a:bodyPr/>
+          <a:lstStyle/>
+          <a:p>
+            <a:endParaRPr lang="en-IN"/>
+          </a:p>
+        </p:txBody>
       </p:sp>
       <p:sp>
         <p:nvSpPr>
@@ -5931,7 +5992,7 @@
           <a:bodyPr wrap="square" rtlCol="0" anchor="ctr"/>
           <a:lstStyle/>
           <a:p>
-            <a:pPr algn="ctr" indent="0" marL="0">
+            <a:pPr marL="0" indent="0" algn="ctr">
               <a:buNone/>
             </a:pPr>
             <a:r>
@@ -5970,7 +6031,7 @@
           <a:bodyPr wrap="square" rtlCol="0" anchor="ctr"/>
           <a:lstStyle/>
           <a:p>
-            <a:pPr indent="0" marL="0">
+            <a:pPr marL="0" indent="0">
               <a:lnSpc>
                 <a:spcPct val="110000"/>
               </a:lnSpc>
@@ -6017,6 +6078,13 @@
             <a:prstDash val="solid"/>
           </a:ln>
         </p:spPr>
+        <p:txBody>
+          <a:bodyPr/>
+          <a:lstStyle/>
+          <a:p>
+            <a:endParaRPr lang="en-IN"/>
+          </a:p>
+        </p:txBody>
       </p:sp>
       <p:sp>
         <p:nvSpPr>
@@ -6037,6 +6105,13 @@
           </a:solidFill>
           <a:ln/>
         </p:spPr>
+        <p:txBody>
+          <a:bodyPr/>
+          <a:lstStyle/>
+          <a:p>
+            <a:endParaRPr lang="en-IN"/>
+          </a:p>
+        </p:txBody>
       </p:sp>
       <p:sp>
         <p:nvSpPr>
@@ -6059,7 +6134,7 @@
           <a:bodyPr wrap="square" rtlCol="0" anchor="ctr"/>
           <a:lstStyle/>
           <a:p>
-            <a:pPr algn="ctr" indent="0" marL="0">
+            <a:pPr marL="0" indent="0" algn="ctr">
               <a:buNone/>
             </a:pPr>
             <a:r>
@@ -6098,7 +6173,7 @@
           <a:bodyPr wrap="square" rtlCol="0" anchor="ctr"/>
           <a:lstStyle/>
           <a:p>
-            <a:pPr indent="0" marL="0">
+            <a:pPr marL="0" indent="0">
               <a:lnSpc>
                 <a:spcPct val="110000"/>
               </a:lnSpc>
@@ -6140,7 +6215,7 @@
           <a:bodyPr wrap="square" rtlCol="0" anchor="ctr"/>
           <a:lstStyle/>
           <a:p>
-            <a:pPr indent="0" marL="0">
+            <a:pPr marL="0" indent="0">
               <a:buNone/>
             </a:pPr>
             <a:r>
@@ -6179,7 +6254,7 @@
           <a:bodyPr wrap="square" rtlCol="0" anchor="ctr"/>
           <a:lstStyle/>
           <a:p>
-            <a:pPr algn="r" indent="0" marL="0">
+            <a:pPr marL="0" indent="0" algn="r">
               <a:buNone/>
             </a:pPr>
             <a:r>
@@ -6213,6 +6288,7 @@
         <a:solidFill>
           <a:srgbClr val="F7F9FC"/>
         </a:solidFill>
+        <a:effectLst/>
       </p:bgPr>
     </p:bg>
     <p:spTree>
@@ -6250,7 +6326,7 @@
           <a:bodyPr wrap="square" rtlCol="0" anchor="ctr"/>
           <a:lstStyle/>
           <a:p>
-            <a:pPr indent="0" marL="0">
+            <a:pPr marL="0" indent="0">
               <a:buNone/>
             </a:pPr>
             <a:r>
@@ -6289,6 +6365,13 @@
           </a:solidFill>
           <a:ln/>
         </p:spPr>
+        <p:txBody>
+          <a:bodyPr/>
+          <a:lstStyle/>
+          <a:p>
+            <a:endParaRPr lang="en-IN"/>
+          </a:p>
+        </p:txBody>
       </p:sp>
       <p:sp>
         <p:nvSpPr>
@@ -6311,7 +6394,7 @@
           <a:bodyPr wrap="square" rtlCol="0" anchor="ctr"/>
           <a:lstStyle/>
           <a:p>
-            <a:pPr algn="ctr" indent="0" marL="0">
+            <a:pPr marL="0" indent="0" algn="ctr">
               <a:buNone/>
             </a:pPr>
             <a:r>
@@ -6352,6 +6435,13 @@
             <a:tailEnd type="triangle"/>
           </a:ln>
         </p:spPr>
+        <p:txBody>
+          <a:bodyPr/>
+          <a:lstStyle/>
+          <a:p>
+            <a:endParaRPr lang="en-IN"/>
+          </a:p>
+        </p:txBody>
       </p:sp>
       <p:sp>
         <p:nvSpPr>
@@ -6374,6 +6464,13 @@
           </a:solidFill>
           <a:ln/>
         </p:spPr>
+        <p:txBody>
+          <a:bodyPr/>
+          <a:lstStyle/>
+          <a:p>
+            <a:endParaRPr lang="en-IN"/>
+          </a:p>
+        </p:txBody>
       </p:sp>
       <p:sp>
         <p:nvSpPr>
@@ -6396,7 +6493,7 @@
           <a:bodyPr wrap="square" rtlCol="0" anchor="ctr"/>
           <a:lstStyle/>
           <a:p>
-            <a:pPr algn="ctr" indent="0" marL="0">
+            <a:pPr marL="0" indent="0" algn="ctr">
               <a:buNone/>
             </a:pPr>
             <a:r>
@@ -6437,6 +6534,13 @@
             <a:tailEnd type="triangle"/>
           </a:ln>
         </p:spPr>
+        <p:txBody>
+          <a:bodyPr/>
+          <a:lstStyle/>
+          <a:p>
+            <a:endParaRPr lang="en-IN"/>
+          </a:p>
+        </p:txBody>
       </p:sp>
       <p:sp>
         <p:nvSpPr>
@@ -6459,6 +6563,13 @@
           </a:solidFill>
           <a:ln/>
         </p:spPr>
+        <p:txBody>
+          <a:bodyPr/>
+          <a:lstStyle/>
+          <a:p>
+            <a:endParaRPr lang="en-IN"/>
+          </a:p>
+        </p:txBody>
       </p:sp>
       <p:sp>
         <p:nvSpPr>
@@ -6481,7 +6592,7 @@
           <a:bodyPr wrap="square" rtlCol="0" anchor="ctr"/>
           <a:lstStyle/>
           <a:p>
-            <a:pPr algn="ctr" indent="0" marL="0">
+            <a:pPr marL="0" indent="0" algn="ctr">
               <a:buNone/>
             </a:pPr>
             <a:r>
@@ -6498,7 +6609,7 @@
             <a:endParaRPr lang="en-US" sz="1250" dirty="0"/>
           </a:p>
           <a:p>
-            <a:pPr algn="ctr" indent="0" marL="0">
+            <a:pPr marL="0" indent="0" algn="ctr">
               <a:buNone/>
             </a:pPr>
             <a:r>
@@ -6537,6 +6648,13 @@
           </a:solidFill>
           <a:ln/>
         </p:spPr>
+        <p:txBody>
+          <a:bodyPr/>
+          <a:lstStyle/>
+          <a:p>
+            <a:endParaRPr lang="en-IN"/>
+          </a:p>
+        </p:txBody>
       </p:sp>
       <p:sp>
         <p:nvSpPr>
@@ -6559,7 +6677,7 @@
           <a:bodyPr wrap="square" rtlCol="0" anchor="ctr"/>
           <a:lstStyle/>
           <a:p>
-            <a:pPr algn="ctr" indent="0" marL="0">
+            <a:pPr marL="0" indent="0" algn="ctr">
               <a:buNone/>
             </a:pPr>
             <a:r>
@@ -6576,7 +6694,7 @@
             <a:endParaRPr lang="en-US" sz="1250" dirty="0"/>
           </a:p>
           <a:p>
-            <a:pPr algn="ctr" indent="0" marL="0">
+            <a:pPr marL="0" indent="0" algn="ctr">
               <a:buNone/>
             </a:pPr>
             <a:r>
@@ -6615,6 +6733,13 @@
           </a:solidFill>
           <a:ln/>
         </p:spPr>
+        <p:txBody>
+          <a:bodyPr/>
+          <a:lstStyle/>
+          <a:p>
+            <a:endParaRPr lang="en-IN"/>
+          </a:p>
+        </p:txBody>
       </p:sp>
       <p:sp>
         <p:nvSpPr>
@@ -6637,7 +6762,7 @@
           <a:bodyPr wrap="square" rtlCol="0" anchor="ctr"/>
           <a:lstStyle/>
           <a:p>
-            <a:pPr algn="ctr" indent="0" marL="0">
+            <a:pPr marL="0" indent="0" algn="ctr">
               <a:buNone/>
             </a:pPr>
             <a:r>
@@ -6654,7 +6779,7 @@
             <a:endParaRPr lang="en-US" sz="1250" dirty="0"/>
           </a:p>
           <a:p>
-            <a:pPr algn="ctr" indent="0" marL="0">
+            <a:pPr marL="0" indent="0" algn="ctr">
               <a:buNone/>
             </a:pPr>
             <a:r>
@@ -6693,6 +6818,13 @@
           </a:solidFill>
           <a:ln/>
         </p:spPr>
+        <p:txBody>
+          <a:bodyPr/>
+          <a:lstStyle/>
+          <a:p>
+            <a:endParaRPr lang="en-IN"/>
+          </a:p>
+        </p:txBody>
       </p:sp>
       <p:sp>
         <p:nvSpPr>
@@ -6715,7 +6847,7 @@
           <a:bodyPr wrap="square" rtlCol="0" anchor="ctr"/>
           <a:lstStyle/>
           <a:p>
-            <a:pPr algn="ctr" indent="0" marL="0">
+            <a:pPr marL="0" indent="0" algn="ctr">
               <a:buNone/>
             </a:pPr>
             <a:r>
@@ -6732,7 +6864,7 @@
             <a:endParaRPr lang="en-US" sz="1250" dirty="0"/>
           </a:p>
           <a:p>
-            <a:pPr algn="ctr" indent="0" marL="0">
+            <a:pPr marL="0" indent="0" algn="ctr">
               <a:buNone/>
             </a:pPr>
             <a:r>
@@ -6772,6 +6904,13 @@
             <a:prstDash val="solid"/>
           </a:ln>
         </p:spPr>
+        <p:txBody>
+          <a:bodyPr/>
+          <a:lstStyle/>
+          <a:p>
+            <a:endParaRPr lang="en-IN"/>
+          </a:p>
+        </p:txBody>
       </p:sp>
       <p:sp>
         <p:nvSpPr>
@@ -6795,6 +6934,13 @@
             <a:prstDash val="solid"/>
           </a:ln>
         </p:spPr>
+        <p:txBody>
+          <a:bodyPr/>
+          <a:lstStyle/>
+          <a:p>
+            <a:endParaRPr lang="en-IN"/>
+          </a:p>
+        </p:txBody>
       </p:sp>
       <p:sp>
         <p:nvSpPr>
@@ -6819,6 +6965,13 @@
             <a:tailEnd type="triangle"/>
           </a:ln>
         </p:spPr>
+        <p:txBody>
+          <a:bodyPr/>
+          <a:lstStyle/>
+          <a:p>
+            <a:endParaRPr lang="en-IN"/>
+          </a:p>
+        </p:txBody>
       </p:sp>
       <p:sp>
         <p:nvSpPr>
@@ -6843,6 +6996,13 @@
             <a:tailEnd type="triangle"/>
           </a:ln>
         </p:spPr>
+        <p:txBody>
+          <a:bodyPr/>
+          <a:lstStyle/>
+          <a:p>
+            <a:endParaRPr lang="en-IN"/>
+          </a:p>
+        </p:txBody>
       </p:sp>
       <p:sp>
         <p:nvSpPr>
@@ -6867,6 +7027,13 @@
             <a:tailEnd type="triangle"/>
           </a:ln>
         </p:spPr>
+        <p:txBody>
+          <a:bodyPr/>
+          <a:lstStyle/>
+          <a:p>
+            <a:endParaRPr lang="en-IN"/>
+          </a:p>
+        </p:txBody>
       </p:sp>
       <p:sp>
         <p:nvSpPr>
@@ -6891,6 +7058,13 @@
             <a:tailEnd type="triangle"/>
           </a:ln>
         </p:spPr>
+        <p:txBody>
+          <a:bodyPr/>
+          <a:lstStyle/>
+          <a:p>
+            <a:endParaRPr lang="en-IN"/>
+          </a:p>
+        </p:txBody>
       </p:sp>
       <p:sp>
         <p:nvSpPr>
@@ -6915,6 +7089,13 @@
             <a:tailEnd type="triangle"/>
           </a:ln>
         </p:spPr>
+        <p:txBody>
+          <a:bodyPr/>
+          <a:lstStyle/>
+          <a:p>
+            <a:endParaRPr lang="en-IN"/>
+          </a:p>
+        </p:txBody>
       </p:sp>
       <p:sp>
         <p:nvSpPr>
@@ -6937,6 +7118,13 @@
           </a:solidFill>
           <a:ln/>
         </p:spPr>
+        <p:txBody>
+          <a:bodyPr/>
+          <a:lstStyle/>
+          <a:p>
+            <a:endParaRPr lang="en-IN"/>
+          </a:p>
+        </p:txBody>
       </p:sp>
       <p:sp>
         <p:nvSpPr>
@@ -6959,7 +7147,7 @@
           <a:bodyPr wrap="square" rtlCol="0" anchor="ctr"/>
           <a:lstStyle/>
           <a:p>
-            <a:pPr algn="ctr" indent="0" marL="0">
+            <a:pPr marL="0" indent="0" algn="ctr">
               <a:buNone/>
             </a:pPr>
             <a:r>
@@ -6998,7 +7186,7 @@
           <a:bodyPr wrap="square" rtlCol="0" anchor="ctr"/>
           <a:lstStyle/>
           <a:p>
-            <a:pPr indent="0" marL="0">
+            <a:pPr marL="0" indent="0">
               <a:buNone/>
             </a:pPr>
             <a:r>
@@ -7037,7 +7225,7 @@
           <a:bodyPr wrap="square" rtlCol="0" anchor="ctr"/>
           <a:lstStyle/>
           <a:p>
-            <a:pPr algn="r" indent="0" marL="0">
+            <a:pPr marL="0" indent="0" algn="r">
               <a:buNone/>
             </a:pPr>
             <a:r>
@@ -7071,6 +7259,7 @@
         <a:solidFill>
           <a:srgbClr val="F7F9FC"/>
         </a:solidFill>
+        <a:effectLst/>
       </p:bgPr>
     </p:bg>
     <p:spTree>
@@ -7108,7 +7297,7 @@
           <a:bodyPr wrap="square" rtlCol="0" anchor="ctr"/>
           <a:lstStyle/>
           <a:p>
-            <a:pPr indent="0" marL="0">
+            <a:pPr marL="0" indent="0">
               <a:buNone/>
             </a:pPr>
             <a:r>
@@ -7149,8 +7338,20 @@
             <a:tbl>
               <a:tblPr/>
               <a:tblGrid>
-                <a:gridCol w="3108960"/>
-                <a:gridCol w="7982712"/>
+                <a:gridCol w="3108960">
+                  <a:extLst>
+                    <a:ext uri="{9D8B030D-6E8A-4147-A177-3AD203B41FA5}">
+                      <a16:colId xmlns:a16="http://schemas.microsoft.com/office/drawing/2014/main" val="20000"/>
+                    </a:ext>
+                  </a:extLst>
+                </a:gridCol>
+                <a:gridCol w="7982712">
+                  <a:extLst>
+                    <a:ext uri="{9D8B030D-6E8A-4147-A177-3AD203B41FA5}">
+                      <a16:colId xmlns:a16="http://schemas.microsoft.com/office/drawing/2014/main" val="20001"/>
+                    </a:ext>
+                  </a:extLst>
+                </a:gridCol>
               </a:tblGrid>
               <a:tr h="484632">
                 <a:tc>
@@ -7158,7 +7359,7 @@
                     <a:bodyPr/>
                     <a:lstStyle/>
                     <a:p>
-                      <a:pPr indent="0" marL="0">
+                      <a:pPr marL="0" indent="0">
                         <a:buNone/>
                       </a:pPr>
                       <a:r>
@@ -7179,7 +7380,7 @@
                       </a:endParaRPr>
                     </a:p>
                   </a:txBody>
-                  <a:tcPr marL="91440" marR="91440" marT="45720" marB="45720" anchor="ctr">
+                  <a:tcPr anchor="ctr">
                     <a:lnL w="9525" cap="flat" cmpd="sng" algn="ctr">
                       <a:solidFill>
                         <a:srgbClr val="DCE3EF"/>
@@ -7226,7 +7427,7 @@
                     <a:bodyPr/>
                     <a:lstStyle/>
                     <a:p>
-                      <a:pPr indent="0" marL="0">
+                      <a:pPr marL="0" indent="0">
                         <a:buNone/>
                       </a:pPr>
                       <a:r>
@@ -7247,7 +7448,7 @@
                       </a:endParaRPr>
                     </a:p>
                   </a:txBody>
-                  <a:tcPr marL="91440" marR="91440" marT="45720" marB="45720" anchor="ctr">
+                  <a:tcPr anchor="ctr">
                     <a:lnL w="9525" cap="flat" cmpd="sng" algn="ctr">
                       <a:solidFill>
                         <a:srgbClr val="DCE3EF"/>
@@ -7289,6 +7490,11 @@
                     </a:solidFill>
                   </a:tcPr>
                 </a:tc>
+                <a:extLst>
+                  <a:ext uri="{0D108BD9-81ED-4DB2-BD59-A6C34878D82A}">
+                    <a16:rowId xmlns:a16="http://schemas.microsoft.com/office/drawing/2014/main" val="10000"/>
+                  </a:ext>
+                </a:extLst>
               </a:tr>
               <a:tr h="484632">
                 <a:tc>
@@ -7296,7 +7502,7 @@
                     <a:bodyPr/>
                     <a:lstStyle/>
                     <a:p>
-                      <a:pPr indent="0" marL="0">
+                      <a:pPr marL="0" indent="0">
                         <a:buNone/>
                       </a:pPr>
                       <a:r>
@@ -7317,7 +7523,7 @@
                       </a:endParaRPr>
                     </a:p>
                   </a:txBody>
-                  <a:tcPr marL="91440" marR="91440" marT="45720" marB="45720" anchor="ctr">
+                  <a:tcPr anchor="ctr">
                     <a:lnL w="9525" cap="flat" cmpd="sng" algn="ctr">
                       <a:solidFill>
                         <a:srgbClr val="DCE3EF"/>
@@ -7364,7 +7570,7 @@
                     <a:bodyPr/>
                     <a:lstStyle/>
                     <a:p>
-                      <a:pPr indent="0" marL="0">
+                      <a:pPr marL="0" indent="0">
                         <a:buNone/>
                       </a:pPr>
                       <a:r>
@@ -7385,7 +7591,7 @@
                       </a:endParaRPr>
                     </a:p>
                   </a:txBody>
-                  <a:tcPr marL="91440" marR="91440" marT="45720" marB="45720" anchor="ctr">
+                  <a:tcPr anchor="ctr">
                     <a:lnL w="9525" cap="flat" cmpd="sng" algn="ctr">
                       <a:solidFill>
                         <a:srgbClr val="DCE3EF"/>
@@ -7427,6 +7633,11 @@
                     </a:solidFill>
                   </a:tcPr>
                 </a:tc>
+                <a:extLst>
+                  <a:ext uri="{0D108BD9-81ED-4DB2-BD59-A6C34878D82A}">
+                    <a16:rowId xmlns:a16="http://schemas.microsoft.com/office/drawing/2014/main" val="10001"/>
+                  </a:ext>
+                </a:extLst>
               </a:tr>
               <a:tr h="484632">
                 <a:tc>
@@ -7434,7 +7645,7 @@
                     <a:bodyPr/>
                     <a:lstStyle/>
                     <a:p>
-                      <a:pPr indent="0" marL="0">
+                      <a:pPr marL="0" indent="0">
                         <a:buNone/>
                       </a:pPr>
                       <a:r>
@@ -7455,7 +7666,7 @@
                       </a:endParaRPr>
                     </a:p>
                   </a:txBody>
-                  <a:tcPr marL="91440" marR="91440" marT="45720" marB="45720" anchor="ctr">
+                  <a:tcPr anchor="ctr">
                     <a:lnL w="9525" cap="flat" cmpd="sng" algn="ctr">
                       <a:solidFill>
                         <a:srgbClr val="DCE3EF"/>
@@ -7502,7 +7713,7 @@
                     <a:bodyPr/>
                     <a:lstStyle/>
                     <a:p>
-                      <a:pPr indent="0" marL="0">
+                      <a:pPr marL="0" indent="0">
                         <a:buNone/>
                       </a:pPr>
                       <a:r>
@@ -7523,7 +7734,7 @@
                       </a:endParaRPr>
                     </a:p>
                   </a:txBody>
-                  <a:tcPr marL="91440" marR="91440" marT="45720" marB="45720" anchor="ctr">
+                  <a:tcPr anchor="ctr">
                     <a:lnL w="9525" cap="flat" cmpd="sng" algn="ctr">
                       <a:solidFill>
                         <a:srgbClr val="DCE3EF"/>
@@ -7565,6 +7776,11 @@
                     </a:solidFill>
                   </a:tcPr>
                 </a:tc>
+                <a:extLst>
+                  <a:ext uri="{0D108BD9-81ED-4DB2-BD59-A6C34878D82A}">
+                    <a16:rowId xmlns:a16="http://schemas.microsoft.com/office/drawing/2014/main" val="10002"/>
+                  </a:ext>
+                </a:extLst>
               </a:tr>
               <a:tr h="484632">
                 <a:tc>
@@ -7572,7 +7788,7 @@
                     <a:bodyPr/>
                     <a:lstStyle/>
                     <a:p>
-                      <a:pPr indent="0" marL="0">
+                      <a:pPr marL="0" indent="0">
                         <a:buNone/>
                       </a:pPr>
                       <a:r>
@@ -7593,7 +7809,7 @@
                       </a:endParaRPr>
                     </a:p>
                   </a:txBody>
-                  <a:tcPr marL="91440" marR="91440" marT="45720" marB="45720" anchor="ctr">
+                  <a:tcPr anchor="ctr">
                     <a:lnL w="9525" cap="flat" cmpd="sng" algn="ctr">
                       <a:solidFill>
                         <a:srgbClr val="DCE3EF"/>
@@ -7640,7 +7856,7 @@
                     <a:bodyPr/>
                     <a:lstStyle/>
                     <a:p>
-                      <a:pPr indent="0" marL="0">
+                      <a:pPr marL="0" indent="0">
                         <a:buNone/>
                       </a:pPr>
                       <a:r>
@@ -7661,7 +7877,7 @@
                       </a:endParaRPr>
                     </a:p>
                   </a:txBody>
-                  <a:tcPr marL="91440" marR="91440" marT="45720" marB="45720" anchor="ctr">
+                  <a:tcPr anchor="ctr">
                     <a:lnL w="9525" cap="flat" cmpd="sng" algn="ctr">
                       <a:solidFill>
                         <a:srgbClr val="DCE3EF"/>
@@ -7703,6 +7919,11 @@
                     </a:solidFill>
                   </a:tcPr>
                 </a:tc>
+                <a:extLst>
+                  <a:ext uri="{0D108BD9-81ED-4DB2-BD59-A6C34878D82A}">
+                    <a16:rowId xmlns:a16="http://schemas.microsoft.com/office/drawing/2014/main" val="10003"/>
+                  </a:ext>
+                </a:extLst>
               </a:tr>
               <a:tr h="484632">
                 <a:tc>
@@ -7710,7 +7931,7 @@
                     <a:bodyPr/>
                     <a:lstStyle/>
                     <a:p>
-                      <a:pPr indent="0" marL="0">
+                      <a:pPr marL="0" indent="0">
                         <a:buNone/>
                       </a:pPr>
                       <a:r>
@@ -7731,7 +7952,7 @@
                       </a:endParaRPr>
                     </a:p>
                   </a:txBody>
-                  <a:tcPr marL="91440" marR="91440" marT="45720" marB="45720" anchor="ctr">
+                  <a:tcPr anchor="ctr">
                     <a:lnL w="9525" cap="flat" cmpd="sng" algn="ctr">
                       <a:solidFill>
                         <a:srgbClr val="DCE3EF"/>
@@ -7778,7 +7999,7 @@
                     <a:bodyPr/>
                     <a:lstStyle/>
                     <a:p>
-                      <a:pPr indent="0" marL="0">
+                      <a:pPr marL="0" indent="0">
                         <a:buNone/>
                       </a:pPr>
                       <a:r>
@@ -7799,7 +8020,7 @@
                       </a:endParaRPr>
                     </a:p>
                   </a:txBody>
-                  <a:tcPr marL="91440" marR="91440" marT="45720" marB="45720" anchor="ctr">
+                  <a:tcPr anchor="ctr">
                     <a:lnL w="9525" cap="flat" cmpd="sng" algn="ctr">
                       <a:solidFill>
                         <a:srgbClr val="DCE3EF"/>
@@ -7841,6 +8062,11 @@
                     </a:solidFill>
                   </a:tcPr>
                 </a:tc>
+                <a:extLst>
+                  <a:ext uri="{0D108BD9-81ED-4DB2-BD59-A6C34878D82A}">
+                    <a16:rowId xmlns:a16="http://schemas.microsoft.com/office/drawing/2014/main" val="10004"/>
+                  </a:ext>
+                </a:extLst>
               </a:tr>
               <a:tr h="484632">
                 <a:tc>
@@ -7848,7 +8074,7 @@
                     <a:bodyPr/>
                     <a:lstStyle/>
                     <a:p>
-                      <a:pPr indent="0" marL="0">
+                      <a:pPr marL="0" indent="0">
                         <a:buNone/>
                       </a:pPr>
                       <a:r>
@@ -7869,7 +8095,7 @@
                       </a:endParaRPr>
                     </a:p>
                   </a:txBody>
-                  <a:tcPr marL="91440" marR="91440" marT="45720" marB="45720" anchor="ctr">
+                  <a:tcPr anchor="ctr">
                     <a:lnL w="9525" cap="flat" cmpd="sng" algn="ctr">
                       <a:solidFill>
                         <a:srgbClr val="DCE3EF"/>
@@ -7916,7 +8142,7 @@
                     <a:bodyPr/>
                     <a:lstStyle/>
                     <a:p>
-                      <a:pPr indent="0" marL="0">
+                      <a:pPr marL="0" indent="0">
                         <a:buNone/>
                       </a:pPr>
                       <a:r>
@@ -7937,7 +8163,7 @@
                       </a:endParaRPr>
                     </a:p>
                   </a:txBody>
-                  <a:tcPr marL="91440" marR="91440" marT="45720" marB="45720" anchor="ctr">
+                  <a:tcPr anchor="ctr">
                     <a:lnL w="9525" cap="flat" cmpd="sng" algn="ctr">
                       <a:solidFill>
                         <a:srgbClr val="DCE3EF"/>
@@ -7979,6 +8205,11 @@
                     </a:solidFill>
                   </a:tcPr>
                 </a:tc>
+                <a:extLst>
+                  <a:ext uri="{0D108BD9-81ED-4DB2-BD59-A6C34878D82A}">
+                    <a16:rowId xmlns:a16="http://schemas.microsoft.com/office/drawing/2014/main" val="10005"/>
+                  </a:ext>
+                </a:extLst>
               </a:tr>
               <a:tr h="484632">
                 <a:tc>
@@ -7986,7 +8217,7 @@
                     <a:bodyPr/>
                     <a:lstStyle/>
                     <a:p>
-                      <a:pPr indent="0" marL="0">
+                      <a:pPr marL="0" indent="0">
                         <a:buNone/>
                       </a:pPr>
                       <a:r>
@@ -8007,7 +8238,7 @@
                       </a:endParaRPr>
                     </a:p>
                   </a:txBody>
-                  <a:tcPr marL="91440" marR="91440" marT="45720" marB="45720" anchor="ctr">
+                  <a:tcPr anchor="ctr">
                     <a:lnL w="9525" cap="flat" cmpd="sng" algn="ctr">
                       <a:solidFill>
                         <a:srgbClr val="DCE3EF"/>
@@ -8054,7 +8285,7 @@
                     <a:bodyPr/>
                     <a:lstStyle/>
                     <a:p>
-                      <a:pPr indent="0" marL="0">
+                      <a:pPr marL="0" indent="0">
                         <a:buNone/>
                       </a:pPr>
                       <a:r>
@@ -8075,7 +8306,7 @@
                       </a:endParaRPr>
                     </a:p>
                   </a:txBody>
-                  <a:tcPr marL="91440" marR="91440" marT="45720" marB="45720" anchor="ctr">
+                  <a:tcPr anchor="ctr">
                     <a:lnL w="9525" cap="flat" cmpd="sng" algn="ctr">
                       <a:solidFill>
                         <a:srgbClr val="DCE3EF"/>
@@ -8117,6 +8348,11 @@
                     </a:solidFill>
                   </a:tcPr>
                 </a:tc>
+                <a:extLst>
+                  <a:ext uri="{0D108BD9-81ED-4DB2-BD59-A6C34878D82A}">
+                    <a16:rowId xmlns:a16="http://schemas.microsoft.com/office/drawing/2014/main" val="10006"/>
+                  </a:ext>
+                </a:extLst>
               </a:tr>
               <a:tr h="484632">
                 <a:tc>
@@ -8124,7 +8360,7 @@
                     <a:bodyPr/>
                     <a:lstStyle/>
                     <a:p>
-                      <a:pPr indent="0" marL="0">
+                      <a:pPr marL="0" indent="0">
                         <a:buNone/>
                       </a:pPr>
                       <a:r>
@@ -8145,7 +8381,7 @@
                       </a:endParaRPr>
                     </a:p>
                   </a:txBody>
-                  <a:tcPr marL="91440" marR="91440" marT="45720" marB="45720" anchor="ctr">
+                  <a:tcPr anchor="ctr">
                     <a:lnL w="9525" cap="flat" cmpd="sng" algn="ctr">
                       <a:solidFill>
                         <a:srgbClr val="DCE3EF"/>
@@ -8192,7 +8428,7 @@
                     <a:bodyPr/>
                     <a:lstStyle/>
                     <a:p>
-                      <a:pPr indent="0" marL="0">
+                      <a:pPr marL="0" indent="0">
                         <a:buNone/>
                       </a:pPr>
                       <a:r>
@@ -8213,7 +8449,7 @@
                       </a:endParaRPr>
                     </a:p>
                   </a:txBody>
-                  <a:tcPr marL="91440" marR="91440" marT="45720" marB="45720" anchor="ctr">
+                  <a:tcPr anchor="ctr">
                     <a:lnL w="9525" cap="flat" cmpd="sng" algn="ctr">
                       <a:solidFill>
                         <a:srgbClr val="DCE3EF"/>
@@ -8255,6 +8491,11 @@
                     </a:solidFill>
                   </a:tcPr>
                 </a:tc>
+                <a:extLst>
+                  <a:ext uri="{0D108BD9-81ED-4DB2-BD59-A6C34878D82A}">
+                    <a16:rowId xmlns:a16="http://schemas.microsoft.com/office/drawing/2014/main" val="10007"/>
+                  </a:ext>
+                </a:extLst>
               </a:tr>
               <a:tr h="484632">
                 <a:tc>
@@ -8262,7 +8503,7 @@
                     <a:bodyPr/>
                     <a:lstStyle/>
                     <a:p>
-                      <a:pPr indent="0" marL="0">
+                      <a:pPr marL="0" indent="0">
                         <a:buNone/>
                       </a:pPr>
                       <a:r>
@@ -8283,7 +8524,7 @@
                       </a:endParaRPr>
                     </a:p>
                   </a:txBody>
-                  <a:tcPr marL="91440" marR="91440" marT="45720" marB="45720" anchor="ctr">
+                  <a:tcPr anchor="ctr">
                     <a:lnL w="9525" cap="flat" cmpd="sng" algn="ctr">
                       <a:solidFill>
                         <a:srgbClr val="DCE3EF"/>
@@ -8330,7 +8571,7 @@
                     <a:bodyPr/>
                     <a:lstStyle/>
                     <a:p>
-                      <a:pPr indent="0" marL="0">
+                      <a:pPr marL="0" indent="0">
                         <a:buNone/>
                       </a:pPr>
                       <a:r>
@@ -8351,7 +8592,7 @@
                       </a:endParaRPr>
                     </a:p>
                   </a:txBody>
-                  <a:tcPr marL="91440" marR="91440" marT="45720" marB="45720" anchor="ctr">
+                  <a:tcPr anchor="ctr">
                     <a:lnL w="9525" cap="flat" cmpd="sng" algn="ctr">
                       <a:solidFill>
                         <a:srgbClr val="DCE3EF"/>
@@ -8393,6 +8634,11 @@
                     </a:solidFill>
                   </a:tcPr>
                 </a:tc>
+                <a:extLst>
+                  <a:ext uri="{0D108BD9-81ED-4DB2-BD59-A6C34878D82A}">
+                    <a16:rowId xmlns:a16="http://schemas.microsoft.com/office/drawing/2014/main" val="10008"/>
+                  </a:ext>
+                </a:extLst>
               </a:tr>
             </a:tbl>
           </a:graphicData>
@@ -8419,7 +8665,7 @@
           <a:bodyPr wrap="square" rtlCol="0" anchor="ctr"/>
           <a:lstStyle/>
           <a:p>
-            <a:pPr indent="0" marL="0">
+            <a:pPr marL="0" indent="0">
               <a:buNone/>
             </a:pPr>
             <a:r>
@@ -8458,7 +8704,7 @@
           <a:bodyPr wrap="square" rtlCol="0" anchor="ctr"/>
           <a:lstStyle/>
           <a:p>
-            <a:pPr algn="r" indent="0" marL="0">
+            <a:pPr marL="0" indent="0" algn="r">
               <a:buNone/>
             </a:pPr>
             <a:r>
@@ -8492,6 +8738,7 @@
         <a:solidFill>
           <a:srgbClr val="13233F"/>
         </a:solidFill>
+        <a:effectLst/>
       </p:bgPr>
     </p:bg>
     <p:spTree>
@@ -8529,7 +8776,7 @@
           <a:bodyPr wrap="square" rtlCol="0" anchor="ctr"/>
           <a:lstStyle/>
           <a:p>
-            <a:pPr indent="0" marL="0">
+            <a:pPr marL="0" indent="0">
               <a:buNone/>
             </a:pPr>
             <a:r>
@@ -8568,6 +8815,13 @@
           </a:solidFill>
           <a:ln/>
         </p:spPr>
+        <p:txBody>
+          <a:bodyPr/>
+          <a:lstStyle/>
+          <a:p>
+            <a:endParaRPr lang="en-IN"/>
+          </a:p>
+        </p:txBody>
       </p:sp>
       <p:sp>
         <p:nvSpPr>
@@ -8588,6 +8842,13 @@
           </a:solidFill>
           <a:ln/>
         </p:spPr>
+        <p:txBody>
+          <a:bodyPr/>
+          <a:lstStyle/>
+          <a:p>
+            <a:endParaRPr lang="en-IN"/>
+          </a:p>
+        </p:txBody>
       </p:sp>
       <p:sp>
         <p:nvSpPr>
@@ -8610,7 +8871,7 @@
           <a:bodyPr wrap="square" rtlCol="0" anchor="ctr"/>
           <a:lstStyle/>
           <a:p>
-            <a:pPr algn="ctr" indent="0" marL="0">
+            <a:pPr marL="0" indent="0" algn="ctr">
               <a:buNone/>
             </a:pPr>
             <a:r>
@@ -8649,7 +8910,7 @@
           <a:bodyPr wrap="square" rtlCol="0" anchor="ctr"/>
           <a:lstStyle/>
           <a:p>
-            <a:pPr algn="ctr" indent="0" marL="0">
+            <a:pPr marL="0" indent="0" algn="ctr">
               <a:buNone/>
             </a:pPr>
             <a:r>
@@ -8688,7 +8949,7 @@
           <a:bodyPr wrap="square" rtlCol="0" anchor="ctr"/>
           <a:lstStyle/>
           <a:p>
-            <a:pPr algn="ctr" indent="0" marL="0">
+            <a:pPr marL="0" indent="0" algn="ctr">
               <a:buNone/>
             </a:pPr>
             <a:r>
@@ -8727,6 +8988,13 @@
           </a:solidFill>
           <a:ln/>
         </p:spPr>
+        <p:txBody>
+          <a:bodyPr/>
+          <a:lstStyle/>
+          <a:p>
+            <a:endParaRPr lang="en-IN"/>
+          </a:p>
+        </p:txBody>
       </p:sp>
       <p:sp>
         <p:nvSpPr>
@@ -8747,6 +9015,13 @@
           </a:solidFill>
           <a:ln/>
         </p:spPr>
+        <p:txBody>
+          <a:bodyPr/>
+          <a:lstStyle/>
+          <a:p>
+            <a:endParaRPr lang="en-IN"/>
+          </a:p>
+        </p:txBody>
       </p:sp>
       <p:sp>
         <p:nvSpPr>
@@ -8769,7 +9044,7 @@
           <a:bodyPr wrap="square" rtlCol="0" anchor="ctr"/>
           <a:lstStyle/>
           <a:p>
-            <a:pPr algn="ctr" indent="0" marL="0">
+            <a:pPr marL="0" indent="0" algn="ctr">
               <a:buNone/>
             </a:pPr>
             <a:r>
@@ -8808,7 +9083,7 @@
           <a:bodyPr wrap="square" rtlCol="0" anchor="ctr"/>
           <a:lstStyle/>
           <a:p>
-            <a:pPr algn="ctr" indent="0" marL="0">
+            <a:pPr marL="0" indent="0" algn="ctr">
               <a:buNone/>
             </a:pPr>
             <a:r>
@@ -8847,7 +9122,7 @@
           <a:bodyPr wrap="square" rtlCol="0" anchor="ctr"/>
           <a:lstStyle/>
           <a:p>
-            <a:pPr algn="ctr" indent="0" marL="0">
+            <a:pPr marL="0" indent="0" algn="ctr">
               <a:buNone/>
             </a:pPr>
             <a:r>
@@ -8886,6 +9161,13 @@
           </a:solidFill>
           <a:ln/>
         </p:spPr>
+        <p:txBody>
+          <a:bodyPr/>
+          <a:lstStyle/>
+          <a:p>
+            <a:endParaRPr lang="en-IN"/>
+          </a:p>
+        </p:txBody>
       </p:sp>
       <p:sp>
         <p:nvSpPr>
@@ -8906,6 +9188,13 @@
           </a:solidFill>
           <a:ln/>
         </p:spPr>
+        <p:txBody>
+          <a:bodyPr/>
+          <a:lstStyle/>
+          <a:p>
+            <a:endParaRPr lang="en-IN"/>
+          </a:p>
+        </p:txBody>
       </p:sp>
       <p:sp>
         <p:nvSpPr>
@@ -8928,7 +9217,7 @@
           <a:bodyPr wrap="square" rtlCol="0" anchor="ctr"/>
           <a:lstStyle/>
           <a:p>
-            <a:pPr algn="ctr" indent="0" marL="0">
+            <a:pPr marL="0" indent="0" algn="ctr">
               <a:buNone/>
             </a:pPr>
             <a:r>
@@ -8967,7 +9256,7 @@
           <a:bodyPr wrap="square" rtlCol="0" anchor="ctr"/>
           <a:lstStyle/>
           <a:p>
-            <a:pPr algn="ctr" indent="0" marL="0">
+            <a:pPr marL="0" indent="0" algn="ctr">
               <a:buNone/>
             </a:pPr>
             <a:r>
@@ -9006,7 +9295,7 @@
           <a:bodyPr wrap="square" rtlCol="0" anchor="ctr"/>
           <a:lstStyle/>
           <a:p>
-            <a:pPr algn="ctr" indent="0" marL="0">
+            <a:pPr marL="0" indent="0" algn="ctr">
               <a:buNone/>
             </a:pPr>
             <a:r>
@@ -9045,6 +9334,13 @@
           </a:solidFill>
           <a:ln/>
         </p:spPr>
+        <p:txBody>
+          <a:bodyPr/>
+          <a:lstStyle/>
+          <a:p>
+            <a:endParaRPr lang="en-IN"/>
+          </a:p>
+        </p:txBody>
       </p:sp>
       <p:sp>
         <p:nvSpPr>
@@ -9065,6 +9361,13 @@
           </a:solidFill>
           <a:ln/>
         </p:spPr>
+        <p:txBody>
+          <a:bodyPr/>
+          <a:lstStyle/>
+          <a:p>
+            <a:endParaRPr lang="en-IN"/>
+          </a:p>
+        </p:txBody>
       </p:sp>
       <p:sp>
         <p:nvSpPr>
@@ -9087,7 +9390,7 @@
           <a:bodyPr wrap="square" rtlCol="0" anchor="ctr"/>
           <a:lstStyle/>
           <a:p>
-            <a:pPr algn="ctr" indent="0" marL="0">
+            <a:pPr marL="0" indent="0" algn="ctr">
               <a:buNone/>
             </a:pPr>
             <a:r>
@@ -9126,7 +9429,7 @@
           <a:bodyPr wrap="square" rtlCol="0" anchor="ctr"/>
           <a:lstStyle/>
           <a:p>
-            <a:pPr algn="ctr" indent="0" marL="0">
+            <a:pPr marL="0" indent="0" algn="ctr">
               <a:buNone/>
             </a:pPr>
             <a:r>
@@ -9165,7 +9468,7 @@
           <a:bodyPr wrap="square" rtlCol="0" anchor="ctr"/>
           <a:lstStyle/>
           <a:p>
-            <a:pPr algn="ctr" indent="0" marL="0">
+            <a:pPr marL="0" indent="0" algn="ctr">
               <a:buNone/>
             </a:pPr>
             <a:r>
@@ -9204,6 +9507,13 @@
           </a:solidFill>
           <a:ln/>
         </p:spPr>
+        <p:txBody>
+          <a:bodyPr/>
+          <a:lstStyle/>
+          <a:p>
+            <a:endParaRPr lang="en-IN"/>
+          </a:p>
+        </p:txBody>
       </p:sp>
       <p:sp>
         <p:nvSpPr>
@@ -9224,6 +9534,13 @@
           </a:solidFill>
           <a:ln/>
         </p:spPr>
+        <p:txBody>
+          <a:bodyPr/>
+          <a:lstStyle/>
+          <a:p>
+            <a:endParaRPr lang="en-IN"/>
+          </a:p>
+        </p:txBody>
       </p:sp>
       <p:sp>
         <p:nvSpPr>
@@ -9246,7 +9563,7 @@
           <a:bodyPr wrap="square" rtlCol="0" anchor="ctr"/>
           <a:lstStyle/>
           <a:p>
-            <a:pPr algn="ctr" indent="0" marL="0">
+            <a:pPr marL="0" indent="0" algn="ctr">
               <a:buNone/>
             </a:pPr>
             <a:r>
@@ -9285,7 +9602,7 @@
           <a:bodyPr wrap="square" rtlCol="0" anchor="ctr"/>
           <a:lstStyle/>
           <a:p>
-            <a:pPr algn="ctr" indent="0" marL="0">
+            <a:pPr marL="0" indent="0" algn="ctr">
               <a:buNone/>
             </a:pPr>
             <a:r>
@@ -9324,7 +9641,7 @@
           <a:bodyPr wrap="square" rtlCol="0" anchor="ctr"/>
           <a:lstStyle/>
           <a:p>
-            <a:pPr algn="ctr" indent="0" marL="0">
+            <a:pPr marL="0" indent="0" algn="ctr">
               <a:buNone/>
             </a:pPr>
             <a:r>
@@ -9363,6 +9680,13 @@
           </a:solidFill>
           <a:ln/>
         </p:spPr>
+        <p:txBody>
+          <a:bodyPr/>
+          <a:lstStyle/>
+          <a:p>
+            <a:endParaRPr lang="en-IN"/>
+          </a:p>
+        </p:txBody>
       </p:sp>
       <p:sp>
         <p:nvSpPr>
@@ -9383,6 +9707,13 @@
           </a:solidFill>
           <a:ln/>
         </p:spPr>
+        <p:txBody>
+          <a:bodyPr/>
+          <a:lstStyle/>
+          <a:p>
+            <a:endParaRPr lang="en-IN"/>
+          </a:p>
+        </p:txBody>
       </p:sp>
       <p:sp>
         <p:nvSpPr>
@@ -9405,7 +9736,7 @@
           <a:bodyPr wrap="square" rtlCol="0" anchor="ctr"/>
           <a:lstStyle/>
           <a:p>
-            <a:pPr algn="ctr" indent="0" marL="0">
+            <a:pPr marL="0" indent="0" algn="ctr">
               <a:buNone/>
             </a:pPr>
             <a:r>
@@ -9444,7 +9775,7 @@
           <a:bodyPr wrap="square" rtlCol="0" anchor="ctr"/>
           <a:lstStyle/>
           <a:p>
-            <a:pPr algn="ctr" indent="0" marL="0">
+            <a:pPr marL="0" indent="0" algn="ctr">
               <a:buNone/>
             </a:pPr>
             <a:r>
@@ -9483,7 +9814,7 @@
           <a:bodyPr wrap="square" rtlCol="0" anchor="ctr"/>
           <a:lstStyle/>
           <a:p>
-            <a:pPr algn="ctr" indent="0" marL="0">
+            <a:pPr marL="0" indent="0" algn="ctr">
               <a:buNone/>
             </a:pPr>
             <a:r>
@@ -9522,6 +9853,13 @@
           </a:solidFill>
           <a:ln/>
         </p:spPr>
+        <p:txBody>
+          <a:bodyPr/>
+          <a:lstStyle/>
+          <a:p>
+            <a:endParaRPr lang="en-IN"/>
+          </a:p>
+        </p:txBody>
       </p:sp>
       <p:sp>
         <p:nvSpPr>
@@ -9542,6 +9880,13 @@
           </a:solidFill>
           <a:ln/>
         </p:spPr>
+        <p:txBody>
+          <a:bodyPr/>
+          <a:lstStyle/>
+          <a:p>
+            <a:endParaRPr lang="en-IN"/>
+          </a:p>
+        </p:txBody>
       </p:sp>
       <p:sp>
         <p:nvSpPr>
@@ -9564,7 +9909,7 @@
           <a:bodyPr wrap="square" rtlCol="0" anchor="ctr"/>
           <a:lstStyle/>
           <a:p>
-            <a:pPr algn="ctr" indent="0" marL="0">
+            <a:pPr marL="0" indent="0" algn="ctr">
               <a:buNone/>
             </a:pPr>
             <a:r>
@@ -9603,7 +9948,7 @@
           <a:bodyPr wrap="square" rtlCol="0" anchor="ctr"/>
           <a:lstStyle/>
           <a:p>
-            <a:pPr algn="ctr" indent="0" marL="0">
+            <a:pPr marL="0" indent="0" algn="ctr">
               <a:buNone/>
             </a:pPr>
             <a:r>
@@ -9642,7 +9987,7 @@
           <a:bodyPr wrap="square" rtlCol="0" anchor="ctr"/>
           <a:lstStyle/>
           <a:p>
-            <a:pPr algn="ctr" indent="0" marL="0">
+            <a:pPr marL="0" indent="0" algn="ctr">
               <a:buNone/>
             </a:pPr>
             <a:r>
@@ -9681,6 +10026,13 @@
           </a:solidFill>
           <a:ln/>
         </p:spPr>
+        <p:txBody>
+          <a:bodyPr/>
+          <a:lstStyle/>
+          <a:p>
+            <a:endParaRPr lang="en-IN"/>
+          </a:p>
+        </p:txBody>
       </p:sp>
       <p:sp>
         <p:nvSpPr>
@@ -9701,6 +10053,13 @@
           </a:solidFill>
           <a:ln/>
         </p:spPr>
+        <p:txBody>
+          <a:bodyPr/>
+          <a:lstStyle/>
+          <a:p>
+            <a:endParaRPr lang="en-IN"/>
+          </a:p>
+        </p:txBody>
       </p:sp>
       <p:sp>
         <p:nvSpPr>
@@ -9723,7 +10082,7 @@
           <a:bodyPr wrap="square" rtlCol="0" anchor="ctr"/>
           <a:lstStyle/>
           <a:p>
-            <a:pPr algn="ctr" indent="0" marL="0">
+            <a:pPr marL="0" indent="0" algn="ctr">
               <a:buNone/>
             </a:pPr>
             <a:r>
@@ -9762,7 +10121,7 @@
           <a:bodyPr wrap="square" rtlCol="0" anchor="ctr"/>
           <a:lstStyle/>
           <a:p>
-            <a:pPr algn="ctr" indent="0" marL="0">
+            <a:pPr marL="0" indent="0" algn="ctr">
               <a:buNone/>
             </a:pPr>
             <a:r>
@@ -9801,7 +10160,7 @@
           <a:bodyPr wrap="square" rtlCol="0" anchor="ctr"/>
           <a:lstStyle/>
           <a:p>
-            <a:pPr algn="ctr" indent="0" marL="0">
+            <a:pPr marL="0" indent="0" algn="ctr">
               <a:buNone/>
             </a:pPr>
             <a:r>
@@ -9840,7 +10199,7 @@
           <a:bodyPr wrap="square" rtlCol="0" anchor="ctr"/>
           <a:lstStyle/>
           <a:p>
-            <a:pPr indent="0" marL="0">
+            <a:pPr marL="0" indent="0">
               <a:buNone/>
             </a:pPr>
             <a:r>
@@ -9879,7 +10238,7 @@
           <a:bodyPr wrap="square" rtlCol="0" anchor="ctr"/>
           <a:lstStyle/>
           <a:p>
-            <a:pPr algn="r" indent="0" marL="0">
+            <a:pPr marL="0" indent="0" algn="r">
               <a:buNone/>
             </a:pPr>
             <a:r>
@@ -9913,6 +10272,7 @@
         <a:solidFill>
           <a:srgbClr val="F7F9FC"/>
         </a:solidFill>
+        <a:effectLst/>
       </p:bgPr>
     </p:bg>
     <p:spTree>
@@ -9950,7 +10310,7 @@
           <a:bodyPr wrap="square" rtlCol="0" anchor="ctr"/>
           <a:lstStyle/>
           <a:p>
-            <a:pPr indent="0" marL="0">
+            <a:pPr marL="0" indent="0">
               <a:buNone/>
             </a:pPr>
             <a:r>
@@ -9970,15 +10330,15 @@
       </p:sp>
       <p:pic>
         <p:nvPicPr>
-          <p:cNvPr id="3" name="Image 0" descr="/home/claude/BankManagementSystem/screenshots/screenshot_1_create_display.png">    </p:cNvPr>
+          <p:cNvPr id="3" name="Image 0" descr="/home/claude/BankManagementSystem/screenshots/screenshot_1_create_display.png"/>
           <p:cNvPicPr>
             <a:picLocks noChangeAspect="1"/>
           </p:cNvPicPr>
           <p:nvPr/>
         </p:nvPicPr>
         <p:blipFill>
-          <a:blip r:embed="rId1"/>
-          <a:srcRect l="0" r="0" t="0" b="0"/>
+          <a:blip r:embed="rId3"/>
+          <a:srcRect/>
           <a:stretch/>
         </p:blipFill>
         <p:spPr>
@@ -9993,15 +10353,15 @@
       </p:pic>
       <p:pic>
         <p:nvPicPr>
-          <p:cNvPr id="4" name="Image 1" descr="/home/claude/BankManagementSystem/screenshots/screenshot_3_top_balance_report.png">    </p:cNvPr>
+          <p:cNvPr id="4" name="Image 1" descr="/home/claude/BankManagementSystem/screenshots/screenshot_3_top_balance_report.png"/>
           <p:cNvPicPr>
             <a:picLocks noChangeAspect="1"/>
           </p:cNvPicPr>
           <p:nvPr/>
         </p:nvPicPr>
         <p:blipFill>
-          <a:blip r:embed="rId2"/>
-          <a:srcRect l="0" r="0" t="0" b="0"/>
+          <a:blip r:embed="rId4"/>
+          <a:srcRect/>
           <a:stretch/>
         </p:blipFill>
         <p:spPr>
@@ -10035,7 +10395,7 @@
           <a:bodyPr wrap="square" rtlCol="0" anchor="ctr"/>
           <a:lstStyle/>
           <a:p>
-            <a:pPr algn="ctr" indent="0" marL="0">
+            <a:pPr marL="0" indent="0" algn="ctr">
               <a:buNone/>
             </a:pPr>
             <a:r>
@@ -10074,7 +10434,7 @@
           <a:bodyPr wrap="square" rtlCol="0" anchor="ctr"/>
           <a:lstStyle/>
           <a:p>
-            <a:pPr algn="ctr" indent="0" marL="0">
+            <a:pPr marL="0" indent="0" algn="ctr">
               <a:buNone/>
             </a:pPr>
             <a:r>
@@ -10113,7 +10473,7 @@
           <a:bodyPr wrap="square" rtlCol="0" anchor="ctr"/>
           <a:lstStyle/>
           <a:p>
-            <a:pPr indent="0" marL="0">
+            <a:pPr marL="0" indent="0">
               <a:buNone/>
             </a:pPr>
             <a:r>
@@ -10152,7 +10512,7 @@
           <a:bodyPr wrap="square" rtlCol="0" anchor="ctr"/>
           <a:lstStyle/>
           <a:p>
-            <a:pPr algn="r" indent="0" marL="0">
+            <a:pPr marL="0" indent="0" algn="r">
               <a:buNone/>
             </a:pPr>
             <a:r>
@@ -10186,6 +10546,7 @@
         <a:solidFill>
           <a:srgbClr val="F7F9FC"/>
         </a:solidFill>
+        <a:effectLst/>
       </p:bgPr>
     </p:bg>
     <p:spTree>
@@ -10223,7 +10584,7 @@
           <a:bodyPr wrap="square" rtlCol="0" anchor="ctr"/>
           <a:lstStyle/>
           <a:p>
-            <a:pPr indent="0" marL="0">
+            <a:pPr marL="0" indent="0">
               <a:buNone/>
             </a:pPr>
             <a:r>
@@ -10264,10 +10625,34 @@
             <a:tbl>
               <a:tblPr/>
               <a:tblGrid>
-                <a:gridCol w="3200400"/>
-                <a:gridCol w="2404872"/>
-                <a:gridCol w="3200400"/>
-                <a:gridCol w="2286000"/>
+                <a:gridCol w="3200400">
+                  <a:extLst>
+                    <a:ext uri="{9D8B030D-6E8A-4147-A177-3AD203B41FA5}">
+                      <a16:colId xmlns:a16="http://schemas.microsoft.com/office/drawing/2014/main" val="20000"/>
+                    </a:ext>
+                  </a:extLst>
+                </a:gridCol>
+                <a:gridCol w="2404872">
+                  <a:extLst>
+                    <a:ext uri="{9D8B030D-6E8A-4147-A177-3AD203B41FA5}">
+                      <a16:colId xmlns:a16="http://schemas.microsoft.com/office/drawing/2014/main" val="20001"/>
+                    </a:ext>
+                  </a:extLst>
+                </a:gridCol>
+                <a:gridCol w="3200400">
+                  <a:extLst>
+                    <a:ext uri="{9D8B030D-6E8A-4147-A177-3AD203B41FA5}">
+                      <a16:colId xmlns:a16="http://schemas.microsoft.com/office/drawing/2014/main" val="20002"/>
+                    </a:ext>
+                  </a:extLst>
+                </a:gridCol>
+                <a:gridCol w="2286000">
+                  <a:extLst>
+                    <a:ext uri="{9D8B030D-6E8A-4147-A177-3AD203B41FA5}">
+                      <a16:colId xmlns:a16="http://schemas.microsoft.com/office/drawing/2014/main" val="20003"/>
+                    </a:ext>
+                  </a:extLst>
+                </a:gridCol>
               </a:tblGrid>
               <a:tr h="502920">
                 <a:tc>
@@ -10275,7 +10660,7 @@
                     <a:bodyPr/>
                     <a:lstStyle/>
                     <a:p>
-                      <a:pPr indent="0" marL="0">
+                      <a:pPr marL="0" indent="0">
                         <a:buNone/>
                       </a:pPr>
                       <a:r>
@@ -10296,7 +10681,7 @@
                       </a:endParaRPr>
                     </a:p>
                   </a:txBody>
-                  <a:tcPr marL="91440" marR="91440" marT="45720" marB="45720" anchor="ctr">
+                  <a:tcPr anchor="ctr">
                     <a:lnL w="9525" cap="flat" cmpd="sng" algn="ctr">
                       <a:solidFill>
                         <a:srgbClr val="DCE3EF"/>
@@ -10343,7 +10728,7 @@
                     <a:bodyPr/>
                     <a:lstStyle/>
                     <a:p>
-                      <a:pPr indent="0" marL="0">
+                      <a:pPr marL="0" indent="0">
                         <a:buNone/>
                       </a:pPr>
                       <a:r>
@@ -10364,7 +10749,7 @@
                       </a:endParaRPr>
                     </a:p>
                   </a:txBody>
-                  <a:tcPr marL="91440" marR="91440" marT="45720" marB="45720" anchor="ctr">
+                  <a:tcPr anchor="ctr">
                     <a:lnL w="9525" cap="flat" cmpd="sng" algn="ctr">
                       <a:solidFill>
                         <a:srgbClr val="DCE3EF"/>
@@ -10411,7 +10796,7 @@
                     <a:bodyPr/>
                     <a:lstStyle/>
                     <a:p>
-                      <a:pPr indent="0" marL="0">
+                      <a:pPr marL="0" indent="0">
                         <a:buNone/>
                       </a:pPr>
                       <a:r>
@@ -10432,7 +10817,7 @@
                       </a:endParaRPr>
                     </a:p>
                   </a:txBody>
-                  <a:tcPr marL="91440" marR="91440" marT="45720" marB="45720" anchor="ctr">
+                  <a:tcPr anchor="ctr">
                     <a:lnL w="9525" cap="flat" cmpd="sng" algn="ctr">
                       <a:solidFill>
                         <a:srgbClr val="DCE3EF"/>
@@ -10479,7 +10864,7 @@
                     <a:bodyPr/>
                     <a:lstStyle/>
                     <a:p>
-                      <a:pPr indent="0" marL="0">
+                      <a:pPr marL="0" indent="0">
                         <a:buNone/>
                       </a:pPr>
                       <a:r>
@@ -10500,7 +10885,7 @@
                       </a:endParaRPr>
                     </a:p>
                   </a:txBody>
-                  <a:tcPr marL="91440" marR="91440" marT="45720" marB="45720" anchor="ctr">
+                  <a:tcPr anchor="ctr">
                     <a:lnL w="9525" cap="flat" cmpd="sng" algn="ctr">
                       <a:solidFill>
                         <a:srgbClr val="DCE3EF"/>
@@ -10542,6 +10927,11 @@
                     </a:solidFill>
                   </a:tcPr>
                 </a:tc>
+                <a:extLst>
+                  <a:ext uri="{0D108BD9-81ED-4DB2-BD59-A6C34878D82A}">
+                    <a16:rowId xmlns:a16="http://schemas.microsoft.com/office/drawing/2014/main" val="10000"/>
+                  </a:ext>
+                </a:extLst>
               </a:tr>
               <a:tr h="502920">
                 <a:tc>
@@ -10549,7 +10939,7 @@
                     <a:bodyPr/>
                     <a:lstStyle/>
                     <a:p>
-                      <a:pPr indent="0" marL="0">
+                      <a:pPr marL="0" indent="0">
                         <a:buNone/>
                       </a:pPr>
                       <a:r>
@@ -10570,7 +10960,7 @@
                       </a:endParaRPr>
                     </a:p>
                   </a:txBody>
-                  <a:tcPr marL="91440" marR="91440" marT="45720" marB="45720" anchor="ctr">
+                  <a:tcPr anchor="ctr">
                     <a:lnL w="9525" cap="flat" cmpd="sng" algn="ctr">
                       <a:solidFill>
                         <a:srgbClr val="DCE3EF"/>
@@ -10617,7 +11007,7 @@
                     <a:bodyPr/>
                     <a:lstStyle/>
                     <a:p>
-                      <a:pPr indent="0" marL="0">
+                      <a:pPr marL="0" indent="0">
                         <a:buNone/>
                       </a:pPr>
                       <a:r>
@@ -10638,7 +11028,7 @@
                       </a:endParaRPr>
                     </a:p>
                   </a:txBody>
-                  <a:tcPr marL="91440" marR="91440" marT="45720" marB="45720" anchor="ctr">
+                  <a:tcPr anchor="ctr">
                     <a:lnL w="9525" cap="flat" cmpd="sng" algn="ctr">
                       <a:solidFill>
                         <a:srgbClr val="DCE3EF"/>
@@ -10685,7 +11075,7 @@
                     <a:bodyPr/>
                     <a:lstStyle/>
                     <a:p>
-                      <a:pPr indent="0" marL="0">
+                      <a:pPr marL="0" indent="0">
                         <a:buNone/>
                       </a:pPr>
                       <a:r>
@@ -10706,7 +11096,7 @@
                       </a:endParaRPr>
                     </a:p>
                   </a:txBody>
-                  <a:tcPr marL="91440" marR="91440" marT="45720" marB="45720" anchor="ctr">
+                  <a:tcPr anchor="ctr">
                     <a:lnL w="9525" cap="flat" cmpd="sng" algn="ctr">
                       <a:solidFill>
                         <a:srgbClr val="DCE3EF"/>
@@ -10753,7 +11143,7 @@
                     <a:bodyPr/>
                     <a:lstStyle/>
                     <a:p>
-                      <a:pPr indent="0" marL="0">
+                      <a:pPr marL="0" indent="0">
                         <a:buNone/>
                       </a:pPr>
                       <a:r>
@@ -10774,7 +11164,7 @@
                       </a:endParaRPr>
                     </a:p>
                   </a:txBody>
-                  <a:tcPr marL="91440" marR="91440" marT="45720" marB="45720" anchor="ctr">
+                  <a:tcPr anchor="ctr">
                     <a:lnL w="9525" cap="flat" cmpd="sng" algn="ctr">
                       <a:solidFill>
                         <a:srgbClr val="DCE3EF"/>
@@ -10816,6 +11206,11 @@
                     </a:solidFill>
                   </a:tcPr>
                 </a:tc>
+                <a:extLst>
+                  <a:ext uri="{0D108BD9-81ED-4DB2-BD59-A6C34878D82A}">
+                    <a16:rowId xmlns:a16="http://schemas.microsoft.com/office/drawing/2014/main" val="10001"/>
+                  </a:ext>
+                </a:extLst>
               </a:tr>
               <a:tr h="502920">
                 <a:tc>
@@ -10823,7 +11218,7 @@
                     <a:bodyPr/>
                     <a:lstStyle/>
                     <a:p>
-                      <a:pPr indent="0" marL="0">
+                      <a:pPr marL="0" indent="0">
                         <a:buNone/>
                       </a:pPr>
                       <a:r>
@@ -10844,7 +11239,7 @@
                       </a:endParaRPr>
                     </a:p>
                   </a:txBody>
-                  <a:tcPr marL="91440" marR="91440" marT="45720" marB="45720" anchor="ctr">
+                  <a:tcPr anchor="ctr">
                     <a:lnL w="9525" cap="flat" cmpd="sng" algn="ctr">
                       <a:solidFill>
                         <a:srgbClr val="DCE3EF"/>
@@ -10891,7 +11286,7 @@
                     <a:bodyPr/>
                     <a:lstStyle/>
                     <a:p>
-                      <a:pPr indent="0" marL="0">
+                      <a:pPr marL="0" indent="0">
                         <a:buNone/>
                       </a:pPr>
                       <a:r>
@@ -10912,7 +11307,7 @@
                       </a:endParaRPr>
                     </a:p>
                   </a:txBody>
-                  <a:tcPr marL="91440" marR="91440" marT="45720" marB="45720" anchor="ctr">
+                  <a:tcPr anchor="ctr">
                     <a:lnL w="9525" cap="flat" cmpd="sng" algn="ctr">
                       <a:solidFill>
                         <a:srgbClr val="DCE3EF"/>
@@ -10959,7 +11354,7 @@
                     <a:bodyPr/>
                     <a:lstStyle/>
                     <a:p>
-                      <a:pPr indent="0" marL="0">
+                      <a:pPr marL="0" indent="0">
                         <a:buNone/>
                       </a:pPr>
                       <a:r>
@@ -10980,7 +11375,7 @@
                       </a:endParaRPr>
                     </a:p>
                   </a:txBody>
-                  <a:tcPr marL="91440" marR="91440" marT="45720" marB="45720" anchor="ctr">
+                  <a:tcPr anchor="ctr">
                     <a:lnL w="9525" cap="flat" cmpd="sng" algn="ctr">
                       <a:solidFill>
                         <a:srgbClr val="DCE3EF"/>
@@ -11027,7 +11422,7 @@
                     <a:bodyPr/>
                     <a:lstStyle/>
                     <a:p>
-                      <a:pPr indent="0" marL="0">
+                      <a:pPr marL="0" indent="0">
                         <a:buNone/>
                       </a:pPr>
                       <a:r>
@@ -11048,7 +11443,7 @@
                       </a:endParaRPr>
                     </a:p>
                   </a:txBody>
-                  <a:tcPr marL="91440" marR="91440" marT="45720" marB="45720" anchor="ctr">
+                  <a:tcPr anchor="ctr">
                     <a:lnL w="9525" cap="flat" cmpd="sng" algn="ctr">
                       <a:solidFill>
                         <a:srgbClr val="DCE3EF"/>
@@ -11090,6 +11485,11 @@
                     </a:solidFill>
                   </a:tcPr>
                 </a:tc>
+                <a:extLst>
+                  <a:ext uri="{0D108BD9-81ED-4DB2-BD59-A6C34878D82A}">
+                    <a16:rowId xmlns:a16="http://schemas.microsoft.com/office/drawing/2014/main" val="10002"/>
+                  </a:ext>
+                </a:extLst>
               </a:tr>
               <a:tr h="502920">
                 <a:tc>
@@ -11097,7 +11497,7 @@
                     <a:bodyPr/>
                     <a:lstStyle/>
                     <a:p>
-                      <a:pPr indent="0" marL="0">
+                      <a:pPr marL="0" indent="0">
                         <a:buNone/>
                       </a:pPr>
                       <a:r>
@@ -11118,7 +11518,7 @@
                       </a:endParaRPr>
                     </a:p>
                   </a:txBody>
-                  <a:tcPr marL="91440" marR="91440" marT="45720" marB="45720" anchor="ctr">
+                  <a:tcPr anchor="ctr">
                     <a:lnL w="9525" cap="flat" cmpd="sng" algn="ctr">
                       <a:solidFill>
                         <a:srgbClr val="DCE3EF"/>
@@ -11165,7 +11565,7 @@
                     <a:bodyPr/>
                     <a:lstStyle/>
                     <a:p>
-                      <a:pPr indent="0" marL="0">
+                      <a:pPr marL="0" indent="0">
                         <a:buNone/>
                       </a:pPr>
                       <a:r>
@@ -11186,7 +11586,7 @@
                       </a:endParaRPr>
                     </a:p>
                   </a:txBody>
-                  <a:tcPr marL="91440" marR="91440" marT="45720" marB="45720" anchor="ctr">
+                  <a:tcPr anchor="ctr">
                     <a:lnL w="9525" cap="flat" cmpd="sng" algn="ctr">
                       <a:solidFill>
                         <a:srgbClr val="DCE3EF"/>
@@ -11233,7 +11633,7 @@
                     <a:bodyPr/>
                     <a:lstStyle/>
                     <a:p>
-                      <a:pPr indent="0" marL="0">
+                      <a:pPr marL="0" indent="0">
                         <a:buNone/>
                       </a:pPr>
                       <a:r>
@@ -11254,7 +11654,7 @@
                       </a:endParaRPr>
                     </a:p>
                   </a:txBody>
-                  <a:tcPr marL="91440" marR="91440" marT="45720" marB="45720" anchor="ctr">
+                  <a:tcPr anchor="ctr">
                     <a:lnL w="9525" cap="flat" cmpd="sng" algn="ctr">
                       <a:solidFill>
                         <a:srgbClr val="DCE3EF"/>
@@ -11301,7 +11701,7 @@
                     <a:bodyPr/>
                     <a:lstStyle/>
                     <a:p>
-                      <a:pPr indent="0" marL="0">
+                      <a:pPr marL="0" indent="0">
                         <a:buNone/>
                       </a:pPr>
                       <a:r>
@@ -11322,7 +11722,7 @@
                       </a:endParaRPr>
                     </a:p>
                   </a:txBody>
-                  <a:tcPr marL="91440" marR="91440" marT="45720" marB="45720" anchor="ctr">
+                  <a:tcPr anchor="ctr">
                     <a:lnL w="9525" cap="flat" cmpd="sng" algn="ctr">
                       <a:solidFill>
                         <a:srgbClr val="DCE3EF"/>
@@ -11364,6 +11764,11 @@
                     </a:solidFill>
                   </a:tcPr>
                 </a:tc>
+                <a:extLst>
+                  <a:ext uri="{0D108BD9-81ED-4DB2-BD59-A6C34878D82A}">
+                    <a16:rowId xmlns:a16="http://schemas.microsoft.com/office/drawing/2014/main" val="10003"/>
+                  </a:ext>
+                </a:extLst>
               </a:tr>
               <a:tr h="502920">
                 <a:tc>
@@ -11371,7 +11776,7 @@
                     <a:bodyPr/>
                     <a:lstStyle/>
                     <a:p>
-                      <a:pPr indent="0" marL="0">
+                      <a:pPr marL="0" indent="0">
                         <a:buNone/>
                       </a:pPr>
                       <a:r>
@@ -11392,7 +11797,7 @@
                       </a:endParaRPr>
                     </a:p>
                   </a:txBody>
-                  <a:tcPr marL="91440" marR="91440" marT="45720" marB="45720" anchor="ctr">
+                  <a:tcPr anchor="ctr">
                     <a:lnL w="9525" cap="flat" cmpd="sng" algn="ctr">
                       <a:solidFill>
                         <a:srgbClr val="DCE3EF"/>
@@ -11439,7 +11844,7 @@
                     <a:bodyPr/>
                     <a:lstStyle/>
                     <a:p>
-                      <a:pPr indent="0" marL="0">
+                      <a:pPr marL="0" indent="0">
                         <a:buNone/>
                       </a:pPr>
                       <a:r>
@@ -11460,7 +11865,7 @@
                       </a:endParaRPr>
                     </a:p>
                   </a:txBody>
-                  <a:tcPr marL="91440" marR="91440" marT="45720" marB="45720" anchor="ctr">
+                  <a:tcPr anchor="ctr">
                     <a:lnL w="9525" cap="flat" cmpd="sng" algn="ctr">
                       <a:solidFill>
                         <a:srgbClr val="DCE3EF"/>
@@ -11507,7 +11912,7 @@
                     <a:bodyPr/>
                     <a:lstStyle/>
                     <a:p>
-                      <a:pPr indent="0" marL="0">
+                      <a:pPr marL="0" indent="0">
                         <a:buNone/>
                       </a:pPr>
                       <a:r>
@@ -11528,7 +11933,7 @@
                       </a:endParaRPr>
                     </a:p>
                   </a:txBody>
-                  <a:tcPr marL="91440" marR="91440" marT="45720" marB="45720" anchor="ctr">
+                  <a:tcPr anchor="ctr">
                     <a:lnL w="9525" cap="flat" cmpd="sng" algn="ctr">
                       <a:solidFill>
                         <a:srgbClr val="DCE3EF"/>
@@ -11575,7 +11980,7 @@
                     <a:bodyPr/>
                     <a:lstStyle/>
                     <a:p>
-                      <a:pPr indent="0" marL="0">
+                      <a:pPr marL="0" indent="0">
                         <a:buNone/>
                       </a:pPr>
                       <a:r>
@@ -11596,7 +12001,7 @@
                       </a:endParaRPr>
                     </a:p>
                   </a:txBody>
-                  <a:tcPr marL="91440" marR="91440" marT="45720" marB="45720" anchor="ctr">
+                  <a:tcPr anchor="ctr">
                     <a:lnL w="9525" cap="flat" cmpd="sng" algn="ctr">
                       <a:solidFill>
                         <a:srgbClr val="DCE3EF"/>
@@ -11638,6 +12043,11 @@
                     </a:solidFill>
                   </a:tcPr>
                 </a:tc>
+                <a:extLst>
+                  <a:ext uri="{0D108BD9-81ED-4DB2-BD59-A6C34878D82A}">
+                    <a16:rowId xmlns:a16="http://schemas.microsoft.com/office/drawing/2014/main" val="10004"/>
+                  </a:ext>
+                </a:extLst>
               </a:tr>
               <a:tr h="502920">
                 <a:tc>
@@ -11645,7 +12055,7 @@
                     <a:bodyPr/>
                     <a:lstStyle/>
                     <a:p>
-                      <a:pPr indent="0" marL="0">
+                      <a:pPr marL="0" indent="0">
                         <a:buNone/>
                       </a:pPr>
                       <a:r>
@@ -11666,7 +12076,7 @@
                       </a:endParaRPr>
                     </a:p>
                   </a:txBody>
-                  <a:tcPr marL="91440" marR="91440" marT="45720" marB="45720" anchor="ctr">
+                  <a:tcPr anchor="ctr">
                     <a:lnL w="9525" cap="flat" cmpd="sng" algn="ctr">
                       <a:solidFill>
                         <a:srgbClr val="DCE3EF"/>
@@ -11713,7 +12123,7 @@
                     <a:bodyPr/>
                     <a:lstStyle/>
                     <a:p>
-                      <a:pPr indent="0" marL="0">
+                      <a:pPr marL="0" indent="0">
                         <a:buNone/>
                       </a:pPr>
                       <a:r>
@@ -11734,7 +12144,7 @@
                       </a:endParaRPr>
                     </a:p>
                   </a:txBody>
-                  <a:tcPr marL="91440" marR="91440" marT="45720" marB="45720" anchor="ctr">
+                  <a:tcPr anchor="ctr">
                     <a:lnL w="9525" cap="flat" cmpd="sng" algn="ctr">
                       <a:solidFill>
                         <a:srgbClr val="DCE3EF"/>
@@ -11781,7 +12191,7 @@
                     <a:bodyPr/>
                     <a:lstStyle/>
                     <a:p>
-                      <a:pPr indent="0" marL="0">
+                      <a:pPr marL="0" indent="0">
                         <a:buNone/>
                       </a:pPr>
                       <a:r>
@@ -11802,7 +12212,7 @@
                       </a:endParaRPr>
                     </a:p>
                   </a:txBody>
-                  <a:tcPr marL="91440" marR="91440" marT="45720" marB="45720" anchor="ctr">
+                  <a:tcPr anchor="ctr">
                     <a:lnL w="9525" cap="flat" cmpd="sng" algn="ctr">
                       <a:solidFill>
                         <a:srgbClr val="DCE3EF"/>
@@ -11849,7 +12259,7 @@
                     <a:bodyPr/>
                     <a:lstStyle/>
                     <a:p>
-                      <a:pPr indent="0" marL="0">
+                      <a:pPr marL="0" indent="0">
                         <a:buNone/>
                       </a:pPr>
                       <a:r>
@@ -11870,7 +12280,7 @@
                       </a:endParaRPr>
                     </a:p>
                   </a:txBody>
-                  <a:tcPr marL="91440" marR="91440" marT="45720" marB="45720" anchor="ctr">
+                  <a:tcPr anchor="ctr">
                     <a:lnL w="9525" cap="flat" cmpd="sng" algn="ctr">
                       <a:solidFill>
                         <a:srgbClr val="DCE3EF"/>
@@ -11912,6 +12322,11 @@
                     </a:solidFill>
                   </a:tcPr>
                 </a:tc>
+                <a:extLst>
+                  <a:ext uri="{0D108BD9-81ED-4DB2-BD59-A6C34878D82A}">
+                    <a16:rowId xmlns:a16="http://schemas.microsoft.com/office/drawing/2014/main" val="10005"/>
+                  </a:ext>
+                </a:extLst>
               </a:tr>
               <a:tr h="502920">
                 <a:tc>
@@ -11919,7 +12334,7 @@
                     <a:bodyPr/>
                     <a:lstStyle/>
                     <a:p>
-                      <a:pPr indent="0" marL="0">
+                      <a:pPr marL="0" indent="0">
                         <a:buNone/>
                       </a:pPr>
                       <a:r>
@@ -11940,7 +12355,7 @@
                       </a:endParaRPr>
                     </a:p>
                   </a:txBody>
-                  <a:tcPr marL="91440" marR="91440" marT="45720" marB="45720" anchor="ctr">
+                  <a:tcPr anchor="ctr">
                     <a:lnL w="9525" cap="flat" cmpd="sng" algn="ctr">
                       <a:solidFill>
                         <a:srgbClr val="DCE3EF"/>
@@ -11987,7 +12402,7 @@
                     <a:bodyPr/>
                     <a:lstStyle/>
                     <a:p>
-                      <a:pPr indent="0" marL="0">
+                      <a:pPr marL="0" indent="0">
                         <a:buNone/>
                       </a:pPr>
                       <a:r>
@@ -12008,7 +12423,7 @@
                       </a:endParaRPr>
                     </a:p>
                   </a:txBody>
-                  <a:tcPr marL="91440" marR="91440" marT="45720" marB="45720" anchor="ctr">
+                  <a:tcPr anchor="ctr">
                     <a:lnL w="9525" cap="flat" cmpd="sng" algn="ctr">
                       <a:solidFill>
                         <a:srgbClr val="DCE3EF"/>
@@ -12055,7 +12470,7 @@
                     <a:bodyPr/>
                     <a:lstStyle/>
                     <a:p>
-                      <a:pPr indent="0" marL="0">
+                      <a:pPr marL="0" indent="0">
                         <a:buNone/>
                       </a:pPr>
                       <a:r>
@@ -12076,7 +12491,7 @@
                       </a:endParaRPr>
                     </a:p>
                   </a:txBody>
-                  <a:tcPr marL="91440" marR="91440" marT="45720" marB="45720" anchor="ctr">
+                  <a:tcPr anchor="ctr">
                     <a:lnL w="9525" cap="flat" cmpd="sng" algn="ctr">
                       <a:solidFill>
                         <a:srgbClr val="DCE3EF"/>
@@ -12123,7 +12538,7 @@
                     <a:bodyPr/>
                     <a:lstStyle/>
                     <a:p>
-                      <a:pPr indent="0" marL="0">
+                      <a:pPr marL="0" indent="0">
                         <a:buNone/>
                       </a:pPr>
                       <a:r>
@@ -12144,7 +12559,7 @@
                       </a:endParaRPr>
                     </a:p>
                   </a:txBody>
-                  <a:tcPr marL="91440" marR="91440" marT="45720" marB="45720" anchor="ctr">
+                  <a:tcPr anchor="ctr">
                     <a:lnL w="9525" cap="flat" cmpd="sng" algn="ctr">
                       <a:solidFill>
                         <a:srgbClr val="DCE3EF"/>
@@ -12186,6 +12601,11 @@
                     </a:solidFill>
                   </a:tcPr>
                 </a:tc>
+                <a:extLst>
+                  <a:ext uri="{0D108BD9-81ED-4DB2-BD59-A6C34878D82A}">
+                    <a16:rowId xmlns:a16="http://schemas.microsoft.com/office/drawing/2014/main" val="10006"/>
+                  </a:ext>
+                </a:extLst>
               </a:tr>
               <a:tr h="502920">
                 <a:tc>
@@ -12193,7 +12613,7 @@
                     <a:bodyPr/>
                     <a:lstStyle/>
                     <a:p>
-                      <a:pPr indent="0" marL="0">
+                      <a:pPr marL="0" indent="0">
                         <a:buNone/>
                       </a:pPr>
                       <a:r>
@@ -12214,7 +12634,7 @@
                       </a:endParaRPr>
                     </a:p>
                   </a:txBody>
-                  <a:tcPr marL="91440" marR="91440" marT="45720" marB="45720" anchor="ctr">
+                  <a:tcPr anchor="ctr">
                     <a:lnL w="9525" cap="flat" cmpd="sng" algn="ctr">
                       <a:solidFill>
                         <a:srgbClr val="DCE3EF"/>
@@ -12261,7 +12681,7 @@
                     <a:bodyPr/>
                     <a:lstStyle/>
                     <a:p>
-                      <a:pPr indent="0" marL="0">
+                      <a:pPr marL="0" indent="0">
                         <a:buNone/>
                       </a:pPr>
                       <a:r>
@@ -12282,7 +12702,7 @@
                       </a:endParaRPr>
                     </a:p>
                   </a:txBody>
-                  <a:tcPr marL="91440" marR="91440" marT="45720" marB="45720" anchor="ctr">
+                  <a:tcPr anchor="ctr">
                     <a:lnL w="9525" cap="flat" cmpd="sng" algn="ctr">
                       <a:solidFill>
                         <a:srgbClr val="DCE3EF"/>
@@ -12329,7 +12749,7 @@
                     <a:bodyPr/>
                     <a:lstStyle/>
                     <a:p>
-                      <a:pPr indent="0" marL="0">
+                      <a:pPr marL="0" indent="0">
                         <a:buNone/>
                       </a:pPr>
                       <a:r>
@@ -12350,7 +12770,7 @@
                       </a:endParaRPr>
                     </a:p>
                   </a:txBody>
-                  <a:tcPr marL="91440" marR="91440" marT="45720" marB="45720" anchor="ctr">
+                  <a:tcPr anchor="ctr">
                     <a:lnL w="9525" cap="flat" cmpd="sng" algn="ctr">
                       <a:solidFill>
                         <a:srgbClr val="DCE3EF"/>
@@ -12397,7 +12817,7 @@
                     <a:bodyPr/>
                     <a:lstStyle/>
                     <a:p>
-                      <a:pPr indent="0" marL="0">
+                      <a:pPr marL="0" indent="0">
                         <a:buNone/>
                       </a:pPr>
                       <a:r>
@@ -12418,7 +12838,7 @@
                       </a:endParaRPr>
                     </a:p>
                   </a:txBody>
-                  <a:tcPr marL="91440" marR="91440" marT="45720" marB="45720" anchor="ctr">
+                  <a:tcPr anchor="ctr">
                     <a:lnL w="9525" cap="flat" cmpd="sng" algn="ctr">
                       <a:solidFill>
                         <a:srgbClr val="DCE3EF"/>
@@ -12460,6 +12880,11 @@
                     </a:solidFill>
                   </a:tcPr>
                 </a:tc>
+                <a:extLst>
+                  <a:ext uri="{0D108BD9-81ED-4DB2-BD59-A6C34878D82A}">
+                    <a16:rowId xmlns:a16="http://schemas.microsoft.com/office/drawing/2014/main" val="10007"/>
+                  </a:ext>
+                </a:extLst>
               </a:tr>
             </a:tbl>
           </a:graphicData>
@@ -12486,7 +12911,7 @@
           <a:bodyPr wrap="square" rtlCol="0" anchor="ctr"/>
           <a:lstStyle/>
           <a:p>
-            <a:pPr indent="0" marL="0">
+            <a:pPr marL="0" indent="0">
               <a:buNone/>
             </a:pPr>
             <a:r>
@@ -12525,7 +12950,7 @@
           <a:bodyPr wrap="square" rtlCol="0" anchor="ctr"/>
           <a:lstStyle/>
           <a:p>
-            <a:pPr indent="0" marL="0">
+            <a:pPr marL="0" indent="0">
               <a:buNone/>
             </a:pPr>
             <a:r>
@@ -12564,7 +12989,7 @@
           <a:bodyPr wrap="square" rtlCol="0" anchor="ctr"/>
           <a:lstStyle/>
           <a:p>
-            <a:pPr algn="r" indent="0" marL="0">
+            <a:pPr marL="0" indent="0" algn="r">
               <a:buNone/>
             </a:pPr>
             <a:r>
@@ -12598,6 +13023,7 @@
         <a:solidFill>
           <a:srgbClr val="F7F9FC"/>
         </a:solidFill>
+        <a:effectLst/>
       </p:bgPr>
     </p:bg>
     <p:spTree>
@@ -12635,7 +13061,7 @@
           <a:bodyPr wrap="square" rtlCol="0" anchor="ctr"/>
           <a:lstStyle/>
           <a:p>
-            <a:pPr indent="0" marL="0">
+            <a:pPr marL="0" indent="0">
               <a:buNone/>
             </a:pPr>
             <a:r>
@@ -12679,6 +13105,13 @@
             <a:prstDash val="solid"/>
           </a:ln>
         </p:spPr>
+        <p:txBody>
+          <a:bodyPr/>
+          <a:lstStyle/>
+          <a:p>
+            <a:endParaRPr lang="en-IN"/>
+          </a:p>
+        </p:txBody>
       </p:sp>
       <p:sp>
         <p:nvSpPr>
@@ -12701,7 +13134,7 @@
           <a:bodyPr wrap="square" rtlCol="0" anchor="ctr"/>
           <a:lstStyle/>
           <a:p>
-            <a:pPr indent="0" marL="0">
+            <a:pPr marL="0" indent="0">
               <a:buNone/>
             </a:pPr>
             <a:r>
@@ -12900,6 +13333,13 @@
           </a:solidFill>
           <a:ln/>
         </p:spPr>
+        <p:txBody>
+          <a:bodyPr/>
+          <a:lstStyle/>
+          <a:p>
+            <a:endParaRPr lang="en-IN"/>
+          </a:p>
+        </p:txBody>
       </p:sp>
       <p:sp>
         <p:nvSpPr>
@@ -12922,7 +13362,7 @@
           <a:bodyPr wrap="square" rtlCol="0" anchor="ctr"/>
           <a:lstStyle/>
           <a:p>
-            <a:pPr indent="0" marL="0">
+            <a:pPr marL="0" indent="0">
               <a:buNone/>
             </a:pPr>
             <a:r>
@@ -13121,7 +13561,7 @@
           <a:bodyPr wrap="square" rtlCol="0" anchor="ctr"/>
           <a:lstStyle/>
           <a:p>
-            <a:pPr indent="0" marL="0">
+            <a:pPr marL="0" indent="0">
               <a:buNone/>
             </a:pPr>
             <a:r>
@@ -13160,7 +13600,7 @@
           <a:bodyPr wrap="square" rtlCol="0" anchor="ctr"/>
           <a:lstStyle/>
           <a:p>
-            <a:pPr algn="r" indent="0" marL="0">
+            <a:pPr marL="0" indent="0" algn="r">
               <a:buNone/>
             </a:pPr>
             <a:r>
@@ -13479,4 +13919,319 @@
     </a:ext>
   </a:extLst>
 </a:theme>
+</file>
+
+<file path=ppt/theme/theme2.xml><?xml version="1.0" encoding="utf-8"?>
+<a:theme xmlns:a="http://schemas.openxmlformats.org/drawingml/2006/main" name="Office Theme">
+  <a:themeElements>
+    <a:clrScheme name="Office">
+      <a:dk1>
+        <a:sysClr val="windowText" lastClr="000000"/>
+      </a:dk1>
+      <a:lt1>
+        <a:sysClr val="window" lastClr="FFFFFF"/>
+      </a:lt1>
+      <a:dk2>
+        <a:srgbClr val="0E2841"/>
+      </a:dk2>
+      <a:lt2>
+        <a:srgbClr val="E8E8E8"/>
+      </a:lt2>
+      <a:accent1>
+        <a:srgbClr val="156082"/>
+      </a:accent1>
+      <a:accent2>
+        <a:srgbClr val="E97132"/>
+      </a:accent2>
+      <a:accent3>
+        <a:srgbClr val="196B24"/>
+      </a:accent3>
+      <a:accent4>
+        <a:srgbClr val="0F9ED5"/>
+      </a:accent4>
+      <a:accent5>
+        <a:srgbClr val="A02B93"/>
+      </a:accent5>
+      <a:accent6>
+        <a:srgbClr val="4EA72E"/>
+      </a:accent6>
+      <a:hlink>
+        <a:srgbClr val="467886"/>
+      </a:hlink>
+      <a:folHlink>
+        <a:srgbClr val="96607D"/>
+      </a:folHlink>
+    </a:clrScheme>
+    <a:fontScheme name="Office">
+      <a:majorFont>
+        <a:latin typeface="Aptos Display" panose="02110004020202020204"/>
+        <a:ea typeface=""/>
+        <a:cs typeface=""/>
+        <a:font script="Jpan" typeface="游ゴシック Light"/>
+        <a:font script="Hang" typeface="맑은 고딕"/>
+        <a:font script="Hans" typeface="等线 Light"/>
+        <a:font script="Hant" typeface="新細明體"/>
+        <a:font script="Arab" typeface="Times New Roman"/>
+        <a:font script="Hebr" typeface="Times New Roman"/>
+        <a:font script="Thai" typeface="Angsana New"/>
+        <a:font script="Ethi" typeface="Nyala"/>
+        <a:font script="Beng" typeface="Vrinda"/>
+        <a:font script="Gujr" typeface="Shruti"/>
+        <a:font script="Khmr" typeface="MoolBoran"/>
+        <a:font script="Knda" typeface="Tunga"/>
+        <a:font script="Guru" typeface="Raavi"/>
+        <a:font script="Cans" typeface="Euphemia"/>
+        <a:font script="Cher" typeface="Plantagenet Cherokee"/>
+        <a:font script="Yiii" typeface="Microsoft Yi Baiti"/>
+        <a:font script="Tibt" typeface="Microsoft Himalaya"/>
+        <a:font script="Thaa" typeface="MV Boli"/>
+        <a:font script="Deva" typeface="Mangal"/>
+        <a:font script="Telu" typeface="Gautami"/>
+        <a:font script="Taml" typeface="Latha"/>
+        <a:font script="Syrc" typeface="Estrangelo Edessa"/>
+        <a:font script="Orya" typeface="Kalinga"/>
+        <a:font script="Mlym" typeface="Kartika"/>
+        <a:font script="Laoo" typeface="DokChampa"/>
+        <a:font script="Sinh" typeface="Iskoola Pota"/>
+        <a:font script="Mong" typeface="Mongolian Baiti"/>
+        <a:font script="Viet" typeface="Times New Roman"/>
+        <a:font script="Uigh" typeface="Microsoft Uighur"/>
+        <a:font script="Geor" typeface="Sylfaen"/>
+        <a:font script="Armn" typeface="Arial"/>
+        <a:font script="Bugi" typeface="Leelawadee UI"/>
+        <a:font script="Bopo" typeface="Microsoft JhengHei"/>
+        <a:font script="Java" typeface="Javanese Text"/>
+        <a:font script="Lisu" typeface="Segoe UI"/>
+        <a:font script="Mymr" typeface="Myanmar Text"/>
+        <a:font script="Nkoo" typeface="Ebrima"/>
+        <a:font script="Olck" typeface="Nirmala UI"/>
+        <a:font script="Osma" typeface="Ebrima"/>
+        <a:font script="Phag" typeface="Phagspa"/>
+        <a:font script="Syrn" typeface="Estrangelo Edessa"/>
+        <a:font script="Syrj" typeface="Estrangelo Edessa"/>
+        <a:font script="Syre" typeface="Estrangelo Edessa"/>
+        <a:font script="Sora" typeface="Nirmala UI"/>
+        <a:font script="Tale" typeface="Microsoft Tai Le"/>
+        <a:font script="Talu" typeface="Microsoft New Tai Lue"/>
+        <a:font script="Tfng" typeface="Ebrima"/>
+      </a:majorFont>
+      <a:minorFont>
+        <a:latin typeface="Aptos" panose="02110004020202020204"/>
+        <a:ea typeface=""/>
+        <a:cs typeface=""/>
+        <a:font script="Jpan" typeface="游ゴシック"/>
+        <a:font script="Hang" typeface="맑은 고딕"/>
+        <a:font script="Hans" typeface="等线"/>
+        <a:font script="Hant" typeface="新細明體"/>
+        <a:font script="Arab" typeface="Arial"/>
+        <a:font script="Hebr" typeface="Arial"/>
+        <a:font script="Thai" typeface="Cordia New"/>
+        <a:font script="Ethi" typeface="Nyala"/>
+        <a:font script="Beng" typeface="Vrinda"/>
+        <a:font script="Gujr" typeface="Shruti"/>
+        <a:font script="Khmr" typeface="DaunPenh"/>
+        <a:font script="Knda" typeface="Tunga"/>
+        <a:font script="Guru" typeface="Raavi"/>
+        <a:font script="Cans" typeface="Euphemia"/>
+        <a:font script="Cher" typeface="Plantagenet Cherokee"/>
+        <a:font script="Yiii" typeface="Microsoft Yi Baiti"/>
+        <a:font script="Tibt" typeface="Microsoft Himalaya"/>
+        <a:font script="Thaa" typeface="MV Boli"/>
+        <a:font script="Deva" typeface="Mangal"/>
+        <a:font script="Telu" typeface="Gautami"/>
+        <a:font script="Taml" typeface="Latha"/>
+        <a:font script="Syrc" typeface="Estrangelo Edessa"/>
+        <a:font script="Orya" typeface="Kalinga"/>
+        <a:font script="Mlym" typeface="Kartika"/>
+        <a:font script="Laoo" typeface="DokChampa"/>
+        <a:font script="Sinh" typeface="Iskoola Pota"/>
+        <a:font script="Mong" typeface="Mongolian Baiti"/>
+        <a:font script="Viet" typeface="Arial"/>
+        <a:font script="Uigh" typeface="Microsoft Uighur"/>
+        <a:font script="Geor" typeface="Sylfaen"/>
+        <a:font script="Armn" typeface="Arial"/>
+        <a:font script="Bugi" typeface="Leelawadee UI"/>
+        <a:font script="Bopo" typeface="Microsoft JhengHei"/>
+        <a:font script="Java" typeface="Javanese Text"/>
+        <a:font script="Lisu" typeface="Segoe UI"/>
+        <a:font script="Mymr" typeface="Myanmar Text"/>
+        <a:font script="Nkoo" typeface="Ebrima"/>
+        <a:font script="Olck" typeface="Nirmala UI"/>
+        <a:font script="Osma" typeface="Ebrima"/>
+        <a:font script="Phag" typeface="Phagspa"/>
+        <a:font script="Syrn" typeface="Estrangelo Edessa"/>
+        <a:font script="Syrj" typeface="Estrangelo Edessa"/>
+        <a:font script="Syre" typeface="Estrangelo Edessa"/>
+        <a:font script="Sora" typeface="Nirmala UI"/>
+        <a:font script="Tale" typeface="Microsoft Tai Le"/>
+        <a:font script="Talu" typeface="Microsoft New Tai Lue"/>
+        <a:font script="Tfng" typeface="Ebrima"/>
+      </a:minorFont>
+    </a:fontScheme>
+    <a:fmtScheme name="Office">
+      <a:fillStyleLst>
+        <a:solidFill>
+          <a:schemeClr val="phClr"/>
+        </a:solidFill>
+        <a:gradFill rotWithShape="1">
+          <a:gsLst>
+            <a:gs pos="0">
+              <a:schemeClr val="phClr">
+                <a:lumMod val="110000"/>
+                <a:satMod val="105000"/>
+                <a:tint val="67000"/>
+              </a:schemeClr>
+            </a:gs>
+            <a:gs pos="50000">
+              <a:schemeClr val="phClr">
+                <a:lumMod val="105000"/>
+                <a:satMod val="103000"/>
+                <a:tint val="73000"/>
+              </a:schemeClr>
+            </a:gs>
+            <a:gs pos="100000">
+              <a:schemeClr val="phClr">
+                <a:lumMod val="105000"/>
+                <a:satMod val="109000"/>
+                <a:tint val="81000"/>
+              </a:schemeClr>
+            </a:gs>
+          </a:gsLst>
+          <a:lin ang="5400000" scaled="0"/>
+        </a:gradFill>
+        <a:gradFill rotWithShape="1">
+          <a:gsLst>
+            <a:gs pos="0">
+              <a:schemeClr val="phClr">
+                <a:satMod val="103000"/>
+                <a:lumMod val="102000"/>
+                <a:tint val="94000"/>
+              </a:schemeClr>
+            </a:gs>
+            <a:gs pos="50000">
+              <a:schemeClr val="phClr">
+                <a:satMod val="110000"/>
+                <a:lumMod val="100000"/>
+                <a:shade val="100000"/>
+              </a:schemeClr>
+            </a:gs>
+            <a:gs pos="100000">
+              <a:schemeClr val="phClr">
+                <a:lumMod val="99000"/>
+                <a:satMod val="120000"/>
+                <a:shade val="78000"/>
+              </a:schemeClr>
+            </a:gs>
+          </a:gsLst>
+          <a:lin ang="5400000" scaled="0"/>
+        </a:gradFill>
+      </a:fillStyleLst>
+      <a:lnStyleLst>
+        <a:ln w="12700" cap="flat" cmpd="sng" algn="ctr">
+          <a:solidFill>
+            <a:schemeClr val="phClr"/>
+          </a:solidFill>
+          <a:prstDash val="solid"/>
+          <a:miter lim="800000"/>
+        </a:ln>
+        <a:ln w="19050" cap="flat" cmpd="sng" algn="ctr">
+          <a:solidFill>
+            <a:schemeClr val="phClr"/>
+          </a:solidFill>
+          <a:prstDash val="solid"/>
+          <a:miter lim="800000"/>
+        </a:ln>
+        <a:ln w="25400" cap="flat" cmpd="sng" algn="ctr">
+          <a:solidFill>
+            <a:schemeClr val="phClr"/>
+          </a:solidFill>
+          <a:prstDash val="solid"/>
+          <a:miter lim="800000"/>
+        </a:ln>
+      </a:lnStyleLst>
+      <a:effectStyleLst>
+        <a:effectStyle>
+          <a:effectLst/>
+        </a:effectStyle>
+        <a:effectStyle>
+          <a:effectLst/>
+        </a:effectStyle>
+        <a:effectStyle>
+          <a:effectLst>
+            <a:outerShdw blurRad="57150" dist="19050" dir="5400000" algn="ctr" rotWithShape="0">
+              <a:srgbClr val="000000">
+                <a:alpha val="63000"/>
+              </a:srgbClr>
+            </a:outerShdw>
+          </a:effectLst>
+        </a:effectStyle>
+      </a:effectStyleLst>
+      <a:bgFillStyleLst>
+        <a:solidFill>
+          <a:schemeClr val="phClr"/>
+        </a:solidFill>
+        <a:solidFill>
+          <a:schemeClr val="phClr">
+            <a:tint val="95000"/>
+            <a:satMod val="170000"/>
+          </a:schemeClr>
+        </a:solidFill>
+        <a:gradFill rotWithShape="1">
+          <a:gsLst>
+            <a:gs pos="0">
+              <a:schemeClr val="phClr">
+                <a:tint val="93000"/>
+                <a:satMod val="150000"/>
+                <a:shade val="98000"/>
+                <a:lumMod val="102000"/>
+              </a:schemeClr>
+            </a:gs>
+            <a:gs pos="50000">
+              <a:schemeClr val="phClr">
+                <a:tint val="98000"/>
+                <a:satMod val="130000"/>
+                <a:shade val="90000"/>
+                <a:lumMod val="103000"/>
+              </a:schemeClr>
+            </a:gs>
+            <a:gs pos="100000">
+              <a:schemeClr val="phClr">
+                <a:shade val="63000"/>
+                <a:satMod val="120000"/>
+              </a:schemeClr>
+            </a:gs>
+          </a:gsLst>
+          <a:lin ang="5400000" scaled="0"/>
+        </a:gradFill>
+      </a:bgFillStyleLst>
+    </a:fmtScheme>
+  </a:themeElements>
+  <a:objectDefaults>
+    <a:lnDef>
+      <a:spPr/>
+      <a:bodyPr/>
+      <a:lstStyle/>
+      <a:style>
+        <a:lnRef idx="2">
+          <a:schemeClr val="accent1"/>
+        </a:lnRef>
+        <a:fillRef idx="0">
+          <a:schemeClr val="accent1"/>
+        </a:fillRef>
+        <a:effectRef idx="1">
+          <a:schemeClr val="accent1"/>
+        </a:effectRef>
+        <a:fontRef idx="minor">
+          <a:schemeClr val="tx1"/>
+        </a:fontRef>
+      </a:style>
+    </a:lnDef>
+  </a:objectDefaults>
+  <a:extraClrSchemeLst/>
+  <a:extLst>
+    <a:ext uri="{05A4C25C-085E-4340-85A3-A5531E510DB2}">
+      <thm15:themeFamily xmlns:thm15="http://schemas.microsoft.com/office/thememl/2012/main" name="Office Theme" id="{2E142A2C-CD16-42D6-873A-C26D2A0506FA}" vid="{1BDDFF52-6CD6-40A5-AB3C-68EB2F1E4D0A}"/>
+    </a:ext>
+  </a:extLst>
+</a:theme>
 </file>
</xml_diff>